<commit_message>
Make cover and closing slides white background per user request
Both the title slide and the closing slide now use pure white (#FFFFFF)
background, matching the rest of the deck instead of navy.

Co-Authored-By: Claude Sonnet 5 <noreply@anthropic.com>
Claude-Session: https://claude.ai/code/session_01AE51ArwYZpfLqHAoebaBte
</commit_message>
<xml_diff>
--- a/reports/TSGEX_Five_Instrument_Yield_Optimization_Report.pptx
+++ b/reports/TSGEX_Five_Instrument_Yield_Optimization_Report.pptx
@@ -2920,7 +2920,7 @@
     <p:bg>
       <p:bgPr>
         <a:solidFill>
-          <a:srgbClr val="0F172A"/>
+          <a:srgbClr val="FFFFFF"/>
         </a:solidFill>
       </p:bgPr>
     </p:bg>
@@ -2946,14 +2946,14 @@
         </p:nvSpPr>
         <p:spPr>
           <a:xfrm>
-            <a:off x="9326880" y="-1645920"/>
+            <a:off x="9509760" y="-1828800"/>
             <a:ext cx="4572000" cy="4572000"/>
           </a:xfrm>
           <a:prstGeom prst="ellipse">
             <a:avLst/>
           </a:prstGeom>
           <a:solidFill>
-            <a:srgbClr val="1E293B"/>
+            <a:srgbClr val="EFF6FF"/>
           </a:solidFill>
           <a:ln/>
         </p:spPr>
@@ -2966,16 +2966,21 @@
         </p:nvSpPr>
         <p:spPr>
           <a:xfrm>
-            <a:off x="-1463040" y="4754880"/>
+            <a:off x="-1645920" y="4937760"/>
             <a:ext cx="3657600" cy="3657600"/>
           </a:xfrm>
           <a:prstGeom prst="ellipse">
             <a:avLst/>
           </a:prstGeom>
           <a:solidFill>
-            <a:srgbClr val="1E293B"/>
+            <a:srgbClr val="F8FAFC"/>
           </a:solidFill>
-          <a:ln/>
+          <a:ln w="9525">
+            <a:solidFill>
+              <a:srgbClr val="E2E8F0"/>
+            </a:solidFill>
+            <a:prstDash val="solid"/>
+          </a:ln>
         </p:spPr>
       </p:sp>
       <p:sp>
@@ -3005,7 +3010,7 @@
             <a:r>
               <a:rPr lang="en-US" sz="1600" b="1" spc="200" kern="0" dirty="0">
                 <a:solidFill>
-                  <a:srgbClr val="93C5FD"/>
+                  <a:srgbClr val="2563EB"/>
                 </a:solidFill>
                 <a:latin typeface="Microsoft JhengHei" pitchFamily="34" charset="0"/>
                 <a:ea typeface="Microsoft JhengHei" pitchFamily="34" charset="-122"/>
@@ -3044,7 +3049,7 @@
             <a:r>
               <a:rPr lang="en-US" sz="4000" b="1" dirty="0">
                 <a:solidFill>
-                  <a:srgbClr val="FFFFFF"/>
+                  <a:srgbClr val="0F172A"/>
                 </a:solidFill>
                 <a:latin typeface="Microsoft JhengHei" pitchFamily="34" charset="0"/>
                 <a:ea typeface="Microsoft JhengHei" pitchFamily="34" charset="-122"/>
@@ -3083,7 +3088,7 @@
             <a:r>
               <a:rPr lang="en-US" sz="1800" dirty="0">
                 <a:solidFill>
-                  <a:srgbClr val="CBD5E1"/>
+                  <a:srgbClr val="334155"/>
                 </a:solidFill>
                 <a:latin typeface="Microsoft JhengHei" pitchFamily="34" charset="0"/>
                 <a:ea typeface="Microsoft JhengHei" pitchFamily="34" charset="-122"/>
@@ -3135,11 +3140,11 @@
             </a:avLst>
           </a:prstGeom>
           <a:solidFill>
-            <a:srgbClr val="1E293B"/>
+            <a:srgbClr val="EFF6FF"/>
           </a:solidFill>
           <a:ln w="9525">
             <a:solidFill>
-              <a:srgbClr val="334155"/>
+              <a:srgbClr val="E2E8F0"/>
             </a:solidFill>
             <a:prstDash val="solid"/>
           </a:ln>
@@ -3172,7 +3177,7 @@
             <a:r>
               <a:rPr lang="en-US" sz="1050" dirty="0">
                 <a:solidFill>
-                  <a:srgbClr val="93C5FD"/>
+                  <a:srgbClr val="2563EB"/>
                 </a:solidFill>
                 <a:latin typeface="Microsoft JhengHei" pitchFamily="34" charset="0"/>
                 <a:ea typeface="Microsoft JhengHei" pitchFamily="34" charset="-122"/>
@@ -3201,11 +3206,11 @@
             </a:avLst>
           </a:prstGeom>
           <a:solidFill>
-            <a:srgbClr val="1E293B"/>
+            <a:srgbClr val="EFF6FF"/>
           </a:solidFill>
           <a:ln w="9525">
             <a:solidFill>
-              <a:srgbClr val="334155"/>
+              <a:srgbClr val="E2E8F0"/>
             </a:solidFill>
             <a:prstDash val="solid"/>
           </a:ln>
@@ -3238,7 +3243,7 @@
             <a:r>
               <a:rPr lang="en-US" sz="1050" dirty="0">
                 <a:solidFill>
-                  <a:srgbClr val="93C5FD"/>
+                  <a:srgbClr val="2563EB"/>
                 </a:solidFill>
                 <a:latin typeface="Microsoft JhengHei" pitchFamily="34" charset="0"/>
                 <a:ea typeface="Microsoft JhengHei" pitchFamily="34" charset="-122"/>
@@ -3267,11 +3272,11 @@
             </a:avLst>
           </a:prstGeom>
           <a:solidFill>
-            <a:srgbClr val="1E293B"/>
+            <a:srgbClr val="EFF6FF"/>
           </a:solidFill>
           <a:ln w="9525">
             <a:solidFill>
-              <a:srgbClr val="334155"/>
+              <a:srgbClr val="E2E8F0"/>
             </a:solidFill>
             <a:prstDash val="solid"/>
           </a:ln>
@@ -3304,7 +3309,7 @@
             <a:r>
               <a:rPr lang="en-US" sz="1050" dirty="0">
                 <a:solidFill>
-                  <a:srgbClr val="93C5FD"/>
+                  <a:srgbClr val="2563EB"/>
                 </a:solidFill>
                 <a:latin typeface="Microsoft JhengHei" pitchFamily="34" charset="0"/>
                 <a:ea typeface="Microsoft JhengHei" pitchFamily="34" charset="-122"/>
@@ -3333,11 +3338,11 @@
             </a:avLst>
           </a:prstGeom>
           <a:solidFill>
-            <a:srgbClr val="1E293B"/>
+            <a:srgbClr val="EFF6FF"/>
           </a:solidFill>
           <a:ln w="9525">
             <a:solidFill>
-              <a:srgbClr val="334155"/>
+              <a:srgbClr val="E2E8F0"/>
             </a:solidFill>
             <a:prstDash val="solid"/>
           </a:ln>
@@ -3370,7 +3375,7 @@
             <a:r>
               <a:rPr lang="en-US" sz="1050" dirty="0">
                 <a:solidFill>
-                  <a:srgbClr val="93C5FD"/>
+                  <a:srgbClr val="2563EB"/>
                 </a:solidFill>
                 <a:latin typeface="Microsoft JhengHei" pitchFamily="34" charset="0"/>
                 <a:ea typeface="Microsoft JhengHei" pitchFamily="34" charset="-122"/>
@@ -3399,11 +3404,11 @@
             </a:avLst>
           </a:prstGeom>
           <a:solidFill>
-            <a:srgbClr val="1E293B"/>
+            <a:srgbClr val="EFF6FF"/>
           </a:solidFill>
           <a:ln w="9525">
             <a:solidFill>
-              <a:srgbClr val="334155"/>
+              <a:srgbClr val="E2E8F0"/>
             </a:solidFill>
             <a:prstDash val="solid"/>
           </a:ln>
@@ -3436,7 +3441,7 @@
             <a:r>
               <a:rPr lang="en-US" sz="1050" dirty="0">
                 <a:solidFill>
-                  <a:srgbClr val="93C5FD"/>
+                  <a:srgbClr val="2563EB"/>
                 </a:solidFill>
                 <a:latin typeface="Microsoft JhengHei" pitchFamily="34" charset="0"/>
                 <a:ea typeface="Microsoft JhengHei" pitchFamily="34" charset="-122"/>
@@ -3475,7 +3480,7 @@
             <a:r>
               <a:rPr lang="en-US" sz="1200" dirty="0">
                 <a:solidFill>
-                  <a:srgbClr val="94A3B8"/>
+                  <a:srgbClr val="334155"/>
                 </a:solidFill>
                 <a:latin typeface="Microsoft JhengHei" pitchFamily="34" charset="0"/>
                 <a:ea typeface="Microsoft JhengHei" pitchFamily="34" charset="-122"/>
@@ -11900,7 +11905,7 @@
     <p:bg>
       <p:bgPr>
         <a:solidFill>
-          <a:srgbClr val="0F172A"/>
+          <a:srgbClr val="FFFFFF"/>
         </a:solidFill>
       </p:bgPr>
     </p:bg>
@@ -11945,7 +11950,7 @@
             <a:r>
               <a:rPr lang="en-US" sz="2800" b="1" dirty="0">
                 <a:solidFill>
-                  <a:srgbClr val="FFFFFF"/>
+                  <a:srgbClr val="0F172A"/>
                 </a:solidFill>
                 <a:latin typeface="Microsoft JhengHei" pitchFamily="34" charset="0"/>
                 <a:ea typeface="Microsoft JhengHei" pitchFamily="34" charset="-122"/>
@@ -11966,15 +11971,13 @@
         <p:spPr>
           <a:xfrm>
             <a:off x="548640" y="1371600"/>
-            <a:ext cx="128016" cy="548640"/>
-          </a:xfrm>
-          <a:prstGeom prst="roundRect">
-            <a:avLst>
-              <a:gd name="adj" fmla="val 28571"/>
-            </a:avLst>
+            <a:ext cx="411480" cy="411480"/>
+          </a:xfrm>
+          <a:prstGeom prst="ellipse">
+            <a:avLst/>
           </a:prstGeom>
           <a:solidFill>
-            <a:srgbClr val="2563EB"/>
+            <a:srgbClr val="EFF6FF"/>
           </a:solidFill>
           <a:ln/>
         </p:spPr>
@@ -11987,8 +11990,47 @@
         </p:nvSpPr>
         <p:spPr>
           <a:xfrm>
-            <a:off x="868680" y="1353312"/>
-            <a:ext cx="2103120" cy="566928"/>
+            <a:off x="548640" y="1371600"/>
+            <a:ext cx="411480" cy="411480"/>
+          </a:xfrm>
+          <a:prstGeom prst="rect">
+            <a:avLst/>
+          </a:prstGeom>
+          <a:noFill/>
+          <a:ln/>
+        </p:spPr>
+        <p:txBody>
+          <a:bodyPr wrap="square" lIns="0" tIns="0" rIns="0" bIns="0" rtlCol="0" anchor="ctr"/>
+          <a:lstStyle/>
+          <a:p>
+            <a:pPr algn="ctr" indent="0" marL="0">
+              <a:buNone/>
+            </a:pPr>
+            <a:r>
+              <a:rPr lang="en-US" sz="1800" b="1" dirty="0">
+                <a:solidFill>
+                  <a:srgbClr val="2563EB"/>
+                </a:solidFill>
+                <a:latin typeface="Microsoft JhengHei" pitchFamily="34" charset="0"/>
+                <a:ea typeface="Microsoft JhengHei" pitchFamily="34" charset="-122"/>
+                <a:cs typeface="Microsoft JhengHei" pitchFamily="34" charset="-120"/>
+              </a:rPr>
+              <a:t>•</a:t>
+            </a:r>
+            <a:endParaRPr lang="en-US" sz="1800" dirty="0"/>
+          </a:p>
+        </p:txBody>
+      </p:sp>
+      <p:sp>
+        <p:nvSpPr>
+          <p:cNvPr id="5" name="Text 3"/>
+          <p:cNvSpPr txBox="1"/>
+          <p:nvPr/>
+        </p:nvSpPr>
+        <p:spPr>
+          <a:xfrm>
+            <a:off x="1097280" y="1353312"/>
+            <a:ext cx="1874520" cy="457200"/>
           </a:xfrm>
           <a:prstGeom prst="rect">
             <a:avLst/>
@@ -12006,7 +12048,7 @@
             <a:r>
               <a:rPr lang="en-US" sz="1250" b="1" dirty="0">
                 <a:solidFill>
-                  <a:srgbClr val="93C5FD"/>
+                  <a:srgbClr val="0F172A"/>
                 </a:solidFill>
                 <a:latin typeface="Microsoft JhengHei" pitchFamily="34" charset="0"/>
                 <a:ea typeface="Microsoft JhengHei" pitchFamily="34" charset="-122"/>
@@ -12020,14 +12062,14 @@
       </p:sp>
       <p:sp>
         <p:nvSpPr>
-          <p:cNvPr id="5" name="Text 3"/>
+          <p:cNvPr id="6" name="Text 4"/>
           <p:cNvSpPr txBox="1"/>
           <p:nvPr/>
         </p:nvSpPr>
         <p:spPr>
           <a:xfrm>
             <a:off x="3017520" y="1353312"/>
-            <a:ext cx="3108960" cy="566928"/>
+            <a:ext cx="3108960" cy="457200"/>
           </a:xfrm>
           <a:prstGeom prst="rect">
             <a:avLst/>
@@ -12048,7 +12090,7 @@
             <a:r>
               <a:rPr lang="en-US" sz="1000" dirty="0">
                 <a:solidFill>
-                  <a:srgbClr val="CBD5E1"/>
+                  <a:srgbClr val="334155"/>
                 </a:solidFill>
                 <a:latin typeface="Microsoft JhengHei" pitchFamily="34" charset="0"/>
                 <a:ea typeface="Microsoft JhengHei" pitchFamily="34" charset="-122"/>
@@ -12062,36 +12104,73 @@
       </p:sp>
       <p:sp>
         <p:nvSpPr>
-          <p:cNvPr id="6" name="Shape 4"/>
+          <p:cNvPr id="7" name="Shape 5"/>
           <p:cNvSpPr/>
           <p:nvPr/>
         </p:nvSpPr>
         <p:spPr>
           <a:xfrm>
             <a:off x="548640" y="2057400"/>
-            <a:ext cx="128016" cy="548640"/>
-          </a:xfrm>
-          <a:prstGeom prst="roundRect">
-            <a:avLst>
-              <a:gd name="adj" fmla="val 28571"/>
-            </a:avLst>
+            <a:ext cx="411480" cy="411480"/>
+          </a:xfrm>
+          <a:prstGeom prst="ellipse">
+            <a:avLst/>
           </a:prstGeom>
           <a:solidFill>
-            <a:srgbClr val="2563EB"/>
+            <a:srgbClr val="EFF6FF"/>
           </a:solidFill>
           <a:ln/>
         </p:spPr>
       </p:sp>
       <p:sp>
         <p:nvSpPr>
-          <p:cNvPr id="7" name="Text 5"/>
+          <p:cNvPr id="8" name="Text 6"/>
           <p:cNvSpPr txBox="1"/>
           <p:nvPr/>
         </p:nvSpPr>
         <p:spPr>
           <a:xfrm>
-            <a:off x="868680" y="2039112"/>
-            <a:ext cx="2103120" cy="566928"/>
+            <a:off x="548640" y="2057400"/>
+            <a:ext cx="411480" cy="411480"/>
+          </a:xfrm>
+          <a:prstGeom prst="rect">
+            <a:avLst/>
+          </a:prstGeom>
+          <a:noFill/>
+          <a:ln/>
+        </p:spPr>
+        <p:txBody>
+          <a:bodyPr wrap="square" lIns="0" tIns="0" rIns="0" bIns="0" rtlCol="0" anchor="ctr"/>
+          <a:lstStyle/>
+          <a:p>
+            <a:pPr algn="ctr" indent="0" marL="0">
+              <a:buNone/>
+            </a:pPr>
+            <a:r>
+              <a:rPr lang="en-US" sz="1800" b="1" dirty="0">
+                <a:solidFill>
+                  <a:srgbClr val="2563EB"/>
+                </a:solidFill>
+                <a:latin typeface="Microsoft JhengHei" pitchFamily="34" charset="0"/>
+                <a:ea typeface="Microsoft JhengHei" pitchFamily="34" charset="-122"/>
+                <a:cs typeface="Microsoft JhengHei" pitchFamily="34" charset="-120"/>
+              </a:rPr>
+              <a:t>•</a:t>
+            </a:r>
+            <a:endParaRPr lang="en-US" sz="1800" dirty="0"/>
+          </a:p>
+        </p:txBody>
+      </p:sp>
+      <p:sp>
+        <p:nvSpPr>
+          <p:cNvPr id="9" name="Text 7"/>
+          <p:cNvSpPr txBox="1"/>
+          <p:nvPr/>
+        </p:nvSpPr>
+        <p:spPr>
+          <a:xfrm>
+            <a:off x="1097280" y="2039112"/>
+            <a:ext cx="1874520" cy="457200"/>
           </a:xfrm>
           <a:prstGeom prst="rect">
             <a:avLst/>
@@ -12109,7 +12188,7 @@
             <a:r>
               <a:rPr lang="en-US" sz="1250" b="1" dirty="0">
                 <a:solidFill>
-                  <a:srgbClr val="93C5FD"/>
+                  <a:srgbClr val="0F172A"/>
                 </a:solidFill>
                 <a:latin typeface="Microsoft JhengHei" pitchFamily="34" charset="0"/>
                 <a:ea typeface="Microsoft JhengHei" pitchFamily="34" charset="-122"/>
@@ -12123,14 +12202,14 @@
       </p:sp>
       <p:sp>
         <p:nvSpPr>
-          <p:cNvPr id="8" name="Text 6"/>
+          <p:cNvPr id="10" name="Text 8"/>
           <p:cNvSpPr txBox="1"/>
           <p:nvPr/>
         </p:nvSpPr>
         <p:spPr>
           <a:xfrm>
             <a:off x="3017520" y="2039112"/>
-            <a:ext cx="3108960" cy="566928"/>
+            <a:ext cx="3108960" cy="457200"/>
           </a:xfrm>
           <a:prstGeom prst="rect">
             <a:avLst/>
@@ -12151,7 +12230,7 @@
             <a:r>
               <a:rPr lang="en-US" sz="1000" dirty="0">
                 <a:solidFill>
-                  <a:srgbClr val="CBD5E1"/>
+                  <a:srgbClr val="334155"/>
                 </a:solidFill>
                 <a:latin typeface="Microsoft JhengHei" pitchFamily="34" charset="0"/>
                 <a:ea typeface="Microsoft JhengHei" pitchFamily="34" charset="-122"/>
@@ -12165,36 +12244,73 @@
       </p:sp>
       <p:sp>
         <p:nvSpPr>
-          <p:cNvPr id="9" name="Shape 7"/>
+          <p:cNvPr id="11" name="Shape 9"/>
           <p:cNvSpPr/>
           <p:nvPr/>
         </p:nvSpPr>
         <p:spPr>
           <a:xfrm>
             <a:off x="548640" y="2743200"/>
-            <a:ext cx="128016" cy="548640"/>
-          </a:xfrm>
-          <a:prstGeom prst="roundRect">
-            <a:avLst>
-              <a:gd name="adj" fmla="val 28571"/>
-            </a:avLst>
+            <a:ext cx="411480" cy="411480"/>
+          </a:xfrm>
+          <a:prstGeom prst="ellipse">
+            <a:avLst/>
           </a:prstGeom>
           <a:solidFill>
-            <a:srgbClr val="2563EB"/>
+            <a:srgbClr val="EFF6FF"/>
           </a:solidFill>
           <a:ln/>
         </p:spPr>
       </p:sp>
       <p:sp>
         <p:nvSpPr>
-          <p:cNvPr id="10" name="Text 8"/>
+          <p:cNvPr id="12" name="Text 10"/>
           <p:cNvSpPr txBox="1"/>
           <p:nvPr/>
         </p:nvSpPr>
         <p:spPr>
           <a:xfrm>
-            <a:off x="868680" y="2724912"/>
-            <a:ext cx="2103120" cy="566928"/>
+            <a:off x="548640" y="2743200"/>
+            <a:ext cx="411480" cy="411480"/>
+          </a:xfrm>
+          <a:prstGeom prst="rect">
+            <a:avLst/>
+          </a:prstGeom>
+          <a:noFill/>
+          <a:ln/>
+        </p:spPr>
+        <p:txBody>
+          <a:bodyPr wrap="square" lIns="0" tIns="0" rIns="0" bIns="0" rtlCol="0" anchor="ctr"/>
+          <a:lstStyle/>
+          <a:p>
+            <a:pPr algn="ctr" indent="0" marL="0">
+              <a:buNone/>
+            </a:pPr>
+            <a:r>
+              <a:rPr lang="en-US" sz="1800" b="1" dirty="0">
+                <a:solidFill>
+                  <a:srgbClr val="2563EB"/>
+                </a:solidFill>
+                <a:latin typeface="Microsoft JhengHei" pitchFamily="34" charset="0"/>
+                <a:ea typeface="Microsoft JhengHei" pitchFamily="34" charset="-122"/>
+                <a:cs typeface="Microsoft JhengHei" pitchFamily="34" charset="-120"/>
+              </a:rPr>
+              <a:t>•</a:t>
+            </a:r>
+            <a:endParaRPr lang="en-US" sz="1800" dirty="0"/>
+          </a:p>
+        </p:txBody>
+      </p:sp>
+      <p:sp>
+        <p:nvSpPr>
+          <p:cNvPr id="13" name="Text 11"/>
+          <p:cNvSpPr txBox="1"/>
+          <p:nvPr/>
+        </p:nvSpPr>
+        <p:spPr>
+          <a:xfrm>
+            <a:off x="1097280" y="2724912"/>
+            <a:ext cx="1874520" cy="457200"/>
           </a:xfrm>
           <a:prstGeom prst="rect">
             <a:avLst/>
@@ -12212,7 +12328,7 @@
             <a:r>
               <a:rPr lang="en-US" sz="1250" b="1" dirty="0">
                 <a:solidFill>
-                  <a:srgbClr val="93C5FD"/>
+                  <a:srgbClr val="0F172A"/>
                 </a:solidFill>
                 <a:latin typeface="Microsoft JhengHei" pitchFamily="34" charset="0"/>
                 <a:ea typeface="Microsoft JhengHei" pitchFamily="34" charset="-122"/>
@@ -12226,14 +12342,14 @@
       </p:sp>
       <p:sp>
         <p:nvSpPr>
-          <p:cNvPr id="11" name="Text 9"/>
+          <p:cNvPr id="14" name="Text 12"/>
           <p:cNvSpPr txBox="1"/>
           <p:nvPr/>
         </p:nvSpPr>
         <p:spPr>
           <a:xfrm>
             <a:off x="3017520" y="2724912"/>
-            <a:ext cx="3108960" cy="566928"/>
+            <a:ext cx="3108960" cy="457200"/>
           </a:xfrm>
           <a:prstGeom prst="rect">
             <a:avLst/>
@@ -12254,7 +12370,7 @@
             <a:r>
               <a:rPr lang="en-US" sz="1000" dirty="0">
                 <a:solidFill>
-                  <a:srgbClr val="CBD5E1"/>
+                  <a:srgbClr val="334155"/>
                 </a:solidFill>
                 <a:latin typeface="Microsoft JhengHei" pitchFamily="34" charset="0"/>
                 <a:ea typeface="Microsoft JhengHei" pitchFamily="34" charset="-122"/>
@@ -12268,36 +12384,73 @@
       </p:sp>
       <p:sp>
         <p:nvSpPr>
-          <p:cNvPr id="12" name="Shape 10"/>
+          <p:cNvPr id="15" name="Shape 13"/>
           <p:cNvSpPr/>
           <p:nvPr/>
         </p:nvSpPr>
         <p:spPr>
           <a:xfrm>
             <a:off x="548640" y="3429000"/>
-            <a:ext cx="128016" cy="548640"/>
-          </a:xfrm>
-          <a:prstGeom prst="roundRect">
-            <a:avLst>
-              <a:gd name="adj" fmla="val 28571"/>
-            </a:avLst>
+            <a:ext cx="411480" cy="411480"/>
+          </a:xfrm>
+          <a:prstGeom prst="ellipse">
+            <a:avLst/>
           </a:prstGeom>
           <a:solidFill>
-            <a:srgbClr val="2563EB"/>
+            <a:srgbClr val="EFF6FF"/>
           </a:solidFill>
           <a:ln/>
         </p:spPr>
       </p:sp>
       <p:sp>
         <p:nvSpPr>
-          <p:cNvPr id="13" name="Text 11"/>
+          <p:cNvPr id="16" name="Text 14"/>
           <p:cNvSpPr txBox="1"/>
           <p:nvPr/>
         </p:nvSpPr>
         <p:spPr>
           <a:xfrm>
-            <a:off x="868680" y="3410712"/>
-            <a:ext cx="2103120" cy="566928"/>
+            <a:off x="548640" y="3429000"/>
+            <a:ext cx="411480" cy="411480"/>
+          </a:xfrm>
+          <a:prstGeom prst="rect">
+            <a:avLst/>
+          </a:prstGeom>
+          <a:noFill/>
+          <a:ln/>
+        </p:spPr>
+        <p:txBody>
+          <a:bodyPr wrap="square" lIns="0" tIns="0" rIns="0" bIns="0" rtlCol="0" anchor="ctr"/>
+          <a:lstStyle/>
+          <a:p>
+            <a:pPr algn="ctr" indent="0" marL="0">
+              <a:buNone/>
+            </a:pPr>
+            <a:r>
+              <a:rPr lang="en-US" sz="1800" b="1" dirty="0">
+                <a:solidFill>
+                  <a:srgbClr val="2563EB"/>
+                </a:solidFill>
+                <a:latin typeface="Microsoft JhengHei" pitchFamily="34" charset="0"/>
+                <a:ea typeface="Microsoft JhengHei" pitchFamily="34" charset="-122"/>
+                <a:cs typeface="Microsoft JhengHei" pitchFamily="34" charset="-120"/>
+              </a:rPr>
+              <a:t>•</a:t>
+            </a:r>
+            <a:endParaRPr lang="en-US" sz="1800" dirty="0"/>
+          </a:p>
+        </p:txBody>
+      </p:sp>
+      <p:sp>
+        <p:nvSpPr>
+          <p:cNvPr id="17" name="Text 15"/>
+          <p:cNvSpPr txBox="1"/>
+          <p:nvPr/>
+        </p:nvSpPr>
+        <p:spPr>
+          <a:xfrm>
+            <a:off x="1097280" y="3410712"/>
+            <a:ext cx="1874520" cy="457200"/>
           </a:xfrm>
           <a:prstGeom prst="rect">
             <a:avLst/>
@@ -12315,7 +12468,7 @@
             <a:r>
               <a:rPr lang="en-US" sz="1250" b="1" dirty="0">
                 <a:solidFill>
-                  <a:srgbClr val="93C5FD"/>
+                  <a:srgbClr val="0F172A"/>
                 </a:solidFill>
                 <a:latin typeface="Microsoft JhengHei" pitchFamily="34" charset="0"/>
                 <a:ea typeface="Microsoft JhengHei" pitchFamily="34" charset="-122"/>
@@ -12329,14 +12482,14 @@
       </p:sp>
       <p:sp>
         <p:nvSpPr>
-          <p:cNvPr id="14" name="Text 12"/>
+          <p:cNvPr id="18" name="Text 16"/>
           <p:cNvSpPr txBox="1"/>
           <p:nvPr/>
         </p:nvSpPr>
         <p:spPr>
           <a:xfrm>
             <a:off x="3017520" y="3410712"/>
-            <a:ext cx="3108960" cy="566928"/>
+            <a:ext cx="3108960" cy="457200"/>
           </a:xfrm>
           <a:prstGeom prst="rect">
             <a:avLst/>
@@ -12357,7 +12510,7 @@
             <a:r>
               <a:rPr lang="en-US" sz="1000" dirty="0">
                 <a:solidFill>
-                  <a:srgbClr val="CBD5E1"/>
+                  <a:srgbClr val="334155"/>
                 </a:solidFill>
                 <a:latin typeface="Microsoft JhengHei" pitchFamily="34" charset="0"/>
                 <a:ea typeface="Microsoft JhengHei" pitchFamily="34" charset="-122"/>
@@ -12371,7 +12524,7 @@
       </p:sp>
       <p:sp>
         <p:nvSpPr>
-          <p:cNvPr id="15" name="Shape 13"/>
+          <p:cNvPr id="19" name="Shape 17"/>
           <p:cNvSpPr/>
           <p:nvPr/>
         </p:nvSpPr>
@@ -12386,11 +12539,11 @@
             </a:avLst>
           </a:prstGeom>
           <a:solidFill>
-            <a:srgbClr val="1E293B"/>
+            <a:srgbClr val="F8FAFC"/>
           </a:solidFill>
           <a:ln w="9525">
             <a:solidFill>
-              <a:srgbClr val="334155"/>
+              <a:srgbClr val="E2E8F0"/>
             </a:solidFill>
             <a:prstDash val="solid"/>
           </a:ln>
@@ -12398,7 +12551,7 @@
       </p:sp>
       <p:sp>
         <p:nvSpPr>
-          <p:cNvPr id="16" name="Text 14"/>
+          <p:cNvPr id="20" name="Text 18"/>
           <p:cNvSpPr txBox="1"/>
           <p:nvPr/>
         </p:nvSpPr>
@@ -12437,7 +12590,7 @@
       </p:sp>
       <p:sp>
         <p:nvSpPr>
-          <p:cNvPr id="17" name="Text 15"/>
+          <p:cNvPr id="21" name="Text 19"/>
           <p:cNvSpPr txBox="1"/>
           <p:nvPr/>
         </p:nvSpPr>
@@ -12465,7 +12618,7 @@
             <a:r>
               <a:rPr lang="en-US" sz="950" dirty="0">
                 <a:solidFill>
-                  <a:srgbClr val="FFFFFF"/>
+                  <a:srgbClr val="0F172A"/>
                 </a:solidFill>
                 <a:latin typeface="Microsoft JhengHei" pitchFamily="34" charset="0"/>
                 <a:ea typeface="Microsoft JhengHei" pitchFamily="34" charset="-122"/>
@@ -12479,7 +12632,7 @@
       </p:sp>
       <p:sp>
         <p:nvSpPr>
-          <p:cNvPr id="18" name="Text 16"/>
+          <p:cNvPr id="22" name="Text 20"/>
           <p:cNvSpPr txBox="1"/>
           <p:nvPr/>
         </p:nvSpPr>
@@ -12504,7 +12657,7 @@
             <a:r>
               <a:rPr lang="en-US" sz="850" dirty="0">
                 <a:solidFill>
-                  <a:srgbClr val="94A3B8"/>
+                  <a:srgbClr val="64748B"/>
                 </a:solidFill>
                 <a:latin typeface="Microsoft JhengHei" pitchFamily="34" charset="0"/>
                 <a:ea typeface="Microsoft JhengHei" pitchFamily="34" charset="-122"/>
@@ -12518,7 +12671,7 @@
       </p:sp>
       <p:sp>
         <p:nvSpPr>
-          <p:cNvPr id="19" name="Text 17"/>
+          <p:cNvPr id="23" name="Text 21"/>
           <p:cNvSpPr txBox="1"/>
           <p:nvPr/>
         </p:nvSpPr>
@@ -12557,7 +12710,7 @@
       </p:sp>
       <p:sp>
         <p:nvSpPr>
-          <p:cNvPr id="20" name="Shape 18"/>
+          <p:cNvPr id="24" name="Shape 22"/>
           <p:cNvSpPr/>
           <p:nvPr/>
         </p:nvSpPr>
@@ -12572,11 +12725,11 @@
             </a:avLst>
           </a:prstGeom>
           <a:solidFill>
-            <a:srgbClr val="1E293B"/>
+            <a:srgbClr val="F8FAFC"/>
           </a:solidFill>
           <a:ln w="9525">
             <a:solidFill>
-              <a:srgbClr val="334155"/>
+              <a:srgbClr val="E2E8F0"/>
             </a:solidFill>
             <a:prstDash val="solid"/>
           </a:ln>
@@ -12584,7 +12737,7 @@
       </p:sp>
       <p:sp>
         <p:nvSpPr>
-          <p:cNvPr id="21" name="Text 19"/>
+          <p:cNvPr id="25" name="Text 23"/>
           <p:cNvSpPr txBox="1"/>
           <p:nvPr/>
         </p:nvSpPr>
@@ -12623,7 +12776,7 @@
       </p:sp>
       <p:sp>
         <p:nvSpPr>
-          <p:cNvPr id="22" name="Text 20"/>
+          <p:cNvPr id="26" name="Text 24"/>
           <p:cNvSpPr txBox="1"/>
           <p:nvPr/>
         </p:nvSpPr>
@@ -12651,7 +12804,7 @@
             <a:r>
               <a:rPr lang="en-US" sz="950" dirty="0">
                 <a:solidFill>
-                  <a:srgbClr val="FFFFFF"/>
+                  <a:srgbClr val="0F172A"/>
                 </a:solidFill>
                 <a:latin typeface="Microsoft JhengHei" pitchFamily="34" charset="0"/>
                 <a:ea typeface="Microsoft JhengHei" pitchFamily="34" charset="-122"/>
@@ -12665,7 +12818,7 @@
       </p:sp>
       <p:sp>
         <p:nvSpPr>
-          <p:cNvPr id="23" name="Text 21"/>
+          <p:cNvPr id="27" name="Text 25"/>
           <p:cNvSpPr txBox="1"/>
           <p:nvPr/>
         </p:nvSpPr>
@@ -12690,7 +12843,7 @@
             <a:r>
               <a:rPr lang="en-US" sz="850" dirty="0">
                 <a:solidFill>
-                  <a:srgbClr val="94A3B8"/>
+                  <a:srgbClr val="64748B"/>
                 </a:solidFill>
                 <a:latin typeface="Microsoft JhengHei" pitchFamily="34" charset="0"/>
                 <a:ea typeface="Microsoft JhengHei" pitchFamily="34" charset="-122"/>
@@ -12704,7 +12857,7 @@
       </p:sp>
       <p:sp>
         <p:nvSpPr>
-          <p:cNvPr id="24" name="Text 22"/>
+          <p:cNvPr id="28" name="Text 26"/>
           <p:cNvSpPr txBox="1"/>
           <p:nvPr/>
         </p:nvSpPr>
@@ -12743,7 +12896,7 @@
       </p:sp>
       <p:sp>
         <p:nvSpPr>
-          <p:cNvPr id="25" name="Shape 23"/>
+          <p:cNvPr id="29" name="Shape 27"/>
           <p:cNvSpPr/>
           <p:nvPr/>
         </p:nvSpPr>
@@ -12758,11 +12911,11 @@
             </a:avLst>
           </a:prstGeom>
           <a:solidFill>
-            <a:srgbClr val="1E293B"/>
+            <a:srgbClr val="F8FAFC"/>
           </a:solidFill>
           <a:ln w="9525">
             <a:solidFill>
-              <a:srgbClr val="334155"/>
+              <a:srgbClr val="E2E8F0"/>
             </a:solidFill>
             <a:prstDash val="solid"/>
           </a:ln>
@@ -12770,7 +12923,7 @@
       </p:sp>
       <p:sp>
         <p:nvSpPr>
-          <p:cNvPr id="26" name="Text 24"/>
+          <p:cNvPr id="30" name="Text 28"/>
           <p:cNvSpPr txBox="1"/>
           <p:nvPr/>
         </p:nvSpPr>
@@ -12809,7 +12962,7 @@
       </p:sp>
       <p:sp>
         <p:nvSpPr>
-          <p:cNvPr id="27" name="Text 25"/>
+          <p:cNvPr id="31" name="Text 29"/>
           <p:cNvSpPr txBox="1"/>
           <p:nvPr/>
         </p:nvSpPr>
@@ -12837,7 +12990,7 @@
             <a:r>
               <a:rPr lang="en-US" sz="950" dirty="0">
                 <a:solidFill>
-                  <a:srgbClr val="FFFFFF"/>
+                  <a:srgbClr val="0F172A"/>
                 </a:solidFill>
                 <a:latin typeface="Microsoft JhengHei" pitchFamily="34" charset="0"/>
                 <a:ea typeface="Microsoft JhengHei" pitchFamily="34" charset="-122"/>
@@ -12851,7 +13004,7 @@
       </p:sp>
       <p:sp>
         <p:nvSpPr>
-          <p:cNvPr id="28" name="Text 26"/>
+          <p:cNvPr id="32" name="Text 30"/>
           <p:cNvSpPr txBox="1"/>
           <p:nvPr/>
         </p:nvSpPr>
@@ -12876,7 +13029,7 @@
             <a:r>
               <a:rPr lang="en-US" sz="850" dirty="0">
                 <a:solidFill>
-                  <a:srgbClr val="94A3B8"/>
+                  <a:srgbClr val="64748B"/>
                 </a:solidFill>
                 <a:latin typeface="Microsoft JhengHei" pitchFamily="34" charset="0"/>
                 <a:ea typeface="Microsoft JhengHei" pitchFamily="34" charset="-122"/>
@@ -12890,7 +13043,7 @@
       </p:sp>
       <p:sp>
         <p:nvSpPr>
-          <p:cNvPr id="29" name="Shape 27"/>
+          <p:cNvPr id="33" name="Shape 31"/>
           <p:cNvSpPr/>
           <p:nvPr/>
         </p:nvSpPr>
@@ -12905,7 +13058,7 @@
           <a:noFill/>
           <a:ln w="9525">
             <a:solidFill>
-              <a:srgbClr val="334155"/>
+              <a:srgbClr val="E2E8F0"/>
             </a:solidFill>
             <a:prstDash val="solid"/>
           </a:ln>
@@ -12913,7 +13066,7 @@
       </p:sp>
       <p:sp>
         <p:nvSpPr>
-          <p:cNvPr id="30" name="Text 28"/>
+          <p:cNvPr id="34" name="Text 32"/>
           <p:cNvSpPr txBox="1"/>
           <p:nvPr/>
         </p:nvSpPr>
@@ -12938,7 +13091,7 @@
             <a:r>
               <a:rPr lang="en-US" sz="1600" b="1" dirty="0">
                 <a:solidFill>
-                  <a:srgbClr val="FFFFFF"/>
+                  <a:srgbClr val="0F172A"/>
                 </a:solidFill>
                 <a:latin typeface="Microsoft JhengHei" pitchFamily="34" charset="0"/>
                 <a:ea typeface="Microsoft JhengHei" pitchFamily="34" charset="-122"/>
@@ -12952,7 +13105,7 @@
       </p:sp>
       <p:sp>
         <p:nvSpPr>
-          <p:cNvPr id="31" name="Text 29"/>
+          <p:cNvPr id="35" name="Text 33"/>
           <p:cNvSpPr txBox="1"/>
           <p:nvPr/>
         </p:nvSpPr>
@@ -12980,7 +13133,7 @@
             <a:r>
               <a:rPr lang="en-US" sz="1300" dirty="0">
                 <a:solidFill>
-                  <a:srgbClr val="CBD5E1"/>
+                  <a:srgbClr val="334155"/>
                 </a:solidFill>
                 <a:latin typeface="Microsoft JhengHei" pitchFamily="34" charset="0"/>
                 <a:ea typeface="Microsoft JhengHei" pitchFamily="34" charset="-122"/>
@@ -12994,7 +13147,7 @@
       </p:sp>
       <p:sp>
         <p:nvSpPr>
-          <p:cNvPr id="32" name="Text 30"/>
+          <p:cNvPr id="36" name="Text 34"/>
           <p:cNvSpPr txBox="1"/>
           <p:nvPr/>
         </p:nvSpPr>
@@ -13019,7 +13172,7 @@
             <a:r>
               <a:rPr lang="en-US" sz="900" dirty="0">
                 <a:solidFill>
-                  <a:srgbClr val="94A3B8"/>
+                  <a:srgbClr val="64748B"/>
                 </a:solidFill>
                 <a:latin typeface="Microsoft JhengHei" pitchFamily="34" charset="0"/>
                 <a:ea typeface="Microsoft JhengHei" pitchFamily="34" charset="-122"/>
@@ -13033,7 +13186,7 @@
       </p:sp>
       <p:sp>
         <p:nvSpPr>
-          <p:cNvPr id="33" name="Text 31"/>
+          <p:cNvPr id="37" name="Text 35"/>
           <p:cNvSpPr txBox="1"/>
           <p:nvPr/>
         </p:nvSpPr>
@@ -13058,7 +13211,7 @@
             <a:r>
               <a:rPr lang="en-US" sz="900" dirty="0">
                 <a:solidFill>
-                  <a:srgbClr val="94A3B8"/>
+                  <a:srgbClr val="64748B"/>
                 </a:solidFill>
                 <a:latin typeface="Microsoft JhengHei" pitchFamily="34" charset="0"/>
                 <a:ea typeface="Microsoft JhengHei" pitchFamily="34" charset="-122"/>

</xml_diff>

<commit_message>
Add rolling wheel-strategy analysis for dual investment products
Adds section 6.4 (with cross-reference in section 7.4) to the report:
after a Dual Investment position converts to BTC, re-selling a "Sell
High" at the same strike each cycle can recover the nominal principal
plus accumulated premium once price reverts to the strike (worked
3-round example). Adds the offsetting scenario where price stays below
strike for an extended period: premium shrinks as the position drifts
further OTM, and FVTPL fair-value accounting still requires recognizing
the unrealized markdown each period even though no loss is "realized."
Mirrors this into the executive PPTX as a new slide (deck now 15 pages).

Co-Authored-By: Claude Sonnet 5 <noreply@anthropic.com>
Claude-Session: https://claude.ai/code/session_01AE51ArwYZpfLqHAoebaBte
</commit_message>
<xml_diff>
--- a/reports/TSGEX_Five_Instrument_Yield_Optimization_Report.pptx
+++ b/reports/TSGEX_Five_Instrument_Yield_Optimization_Report.pptx
@@ -19,9 +19,10 @@
     <p:sldId id="267" r:id="rId13"/>
     <p:sldId id="268" r:id="rId14"/>
     <p:sldId id="269" r:id="rId15"/>
+    <p:sldId id="270" r:id="rId16"/>
   </p:sldIdLst>
   <p:notesMasterIdLst>
-    <p:notesMasterId r:id="rId16"/>
+    <p:notesMasterId r:id="rId17"/>
   </p:notesMasterIdLst>
   <p:sldSz cx="12192000" cy="6858000"/>
   <p:notesSz cx="6858000" cy="12192000"/>
@@ -1903,6 +1904,94 @@
 </p:notes>
 </file>
 
+<file path=ppt/notesSlides/notesSlide15.xml><?xml version="1.0" encoding="utf-8"?>
+<p:notes xmlns:a="http://schemas.openxmlformats.org/drawingml/2006/main" xmlns:r="http://schemas.openxmlformats.org/officeDocument/2006/relationships" xmlns:p="http://schemas.openxmlformats.org/presentationml/2006/main">
+  <p:cSld>
+    <p:spTree>
+      <p:nvGrpSpPr>
+        <p:cNvPr id="1" name=""/>
+        <p:cNvGrpSpPr/>
+        <p:nvPr/>
+      </p:nvGrpSpPr>
+      <p:grpSpPr>
+        <a:xfrm>
+          <a:off x="0" y="0"/>
+          <a:ext cx="0" cy="0"/>
+          <a:chOff x="0" y="0"/>
+          <a:chExt cx="0" cy="0"/>
+        </a:xfrm>
+      </p:grpSpPr>
+      <p:sp>
+        <p:nvSpPr>
+          <p:cNvPr id="2" name="Slide Image Placeholder 1"/>
+          <p:cNvSpPr>
+            <a:spLocks noGrp="1" noRot="1" noChangeAspect="1"/>
+          </p:cNvSpPr>
+          <p:nvPr>
+            <p:ph type="sldImg"/>
+          </p:nvPr>
+        </p:nvSpPr>
+        <p:spPr/>
+      </p:sp>
+      <p:sp>
+        <p:nvSpPr>
+          <p:cNvPr id="3" name="Notes Placeholder 2"/>
+          <p:cNvSpPr>
+            <a:spLocks noGrp="1"/>
+          </p:cNvSpPr>
+          <p:nvPr>
+            <p:ph type="body" idx="1"/>
+          </p:nvPr>
+        </p:nvSpPr>
+        <p:spPr/>
+        <p:txBody>
+          <a:bodyPr/>
+          <a:lstStyle/>
+          <a:p>
+            <a:r>
+              <a:rPr lang="en-US" dirty="0"/>
+              <a:t/>
+            </a:r>
+            <a:endParaRPr lang="en-US" dirty="0"/>
+          </a:p>
+        </p:txBody>
+      </p:sp>
+      <p:sp>
+        <p:nvSpPr>
+          <p:cNvPr id="4" name="Slide Number Placeholder 3"/>
+          <p:cNvSpPr>
+            <a:spLocks noGrp="1"/>
+          </p:cNvSpPr>
+          <p:nvPr>
+            <p:ph type="sldNum" sz="quarter" idx="10"/>
+          </p:nvPr>
+        </p:nvSpPr>
+        <p:spPr/>
+        <p:txBody>
+          <a:bodyPr/>
+          <a:lstStyle/>
+          <a:p>
+            <a:fld id="{F7021451-1387-4CA6-816F-3879F97B5CBC}" type="slidenum">
+              <a:rPr lang="en-US"/>
+              <a:t>15</a:t>
+            </a:fld>
+            <a:endParaRPr lang="en-US"/>
+          </a:p>
+        </p:txBody>
+      </p:sp>
+    </p:spTree>
+    <p:extLst>
+      <p:ext uri="{BB962C8B-B14F-4D97-AF65-F5344CB8AC3E}">
+        <p14:creationId xmlns:p14="http://schemas.microsoft.com/office/powerpoint/2010/main" val="1024086991"/>
+      </p:ext>
+    </p:extLst>
+  </p:cSld>
+  <p:clrMapOvr>
+    <a:masterClrMapping/>
+  </p:clrMapOvr>
+</p:notes>
+</file>
+
 <file path=ppt/notesSlides/notesSlide2.xml><?xml version="1.0" encoding="utf-8"?>
 <p:notes xmlns:a="http://schemas.openxmlformats.org/drawingml/2006/main" xmlns:r="http://schemas.openxmlformats.org/officeDocument/2006/relationships" xmlns:p="http://schemas.openxmlformats.org/presentationml/2006/main">
   <p:cSld>
@@ -3596,6 +3685,2000 @@
                 <a:ea typeface="Microsoft JhengHei" pitchFamily="34" charset="-122"/>
                 <a:cs typeface="Microsoft JhengHei" pitchFamily="34" charset="-120"/>
               </a:rPr>
+              <a:t>④ 進階策略：轉換後之滾動掛單（"Wheel" 策略）</a:t>
+            </a:r>
+            <a:endParaRPr lang="en-US" sz="2800" dirty="0"/>
+          </a:p>
+        </p:txBody>
+      </p:sp>
+      <p:sp>
+        <p:nvSpPr>
+          <p:cNvPr id="3" name="Text 1"/>
+          <p:cNvSpPr txBox="1"/>
+          <p:nvPr/>
+        </p:nvSpPr>
+        <p:spPr>
+          <a:xfrm>
+            <a:off x="548640" y="960120"/>
+            <a:ext cx="11094415" cy="365760"/>
+          </a:xfrm>
+          <a:prstGeom prst="rect">
+            <a:avLst/>
+          </a:prstGeom>
+          <a:noFill/>
+          <a:ln/>
+        </p:spPr>
+        <p:txBody>
+          <a:bodyPr wrap="square" lIns="0" tIns="0" rIns="0" bIns="0" rtlCol="0" anchor="ctr"/>
+          <a:lstStyle/>
+          <a:p>
+            <a:pPr algn="l" indent="0" marL="0">
+              <a:buNone/>
+            </a:pPr>
+            <a:r>
+              <a:rPr lang="en-US" sz="1300" dirty="0">
+                <a:solidFill>
+                  <a:srgbClr val="64748B"/>
+                </a:solidFill>
+                <a:latin typeface="Microsoft JhengHei" pitchFamily="34" charset="0"/>
+                <a:ea typeface="Microsoft JhengHei" pitchFamily="34" charset="-122"/>
+                <a:cs typeface="Microsoft JhengHei" pitchFamily="34" charset="-120"/>
+              </a:rPr>
+              <a:t>本金轉為 BTC 後不認賠平倉，改以同一行使價反向掛「高賣」等待價格回升</a:t>
+            </a:r>
+            <a:endParaRPr lang="en-US" sz="1300" dirty="0"/>
+          </a:p>
+        </p:txBody>
+      </p:sp>
+      <p:sp>
+        <p:nvSpPr>
+          <p:cNvPr id="4" name="Shape 2"/>
+          <p:cNvSpPr/>
+          <p:nvPr/>
+        </p:nvSpPr>
+        <p:spPr>
+          <a:xfrm>
+            <a:off x="548640" y="1463040"/>
+            <a:ext cx="5440680" cy="1920240"/>
+          </a:xfrm>
+          <a:prstGeom prst="roundRect">
+            <a:avLst>
+              <a:gd name="adj" fmla="val 3810"/>
+            </a:avLst>
+          </a:prstGeom>
+          <a:solidFill>
+            <a:srgbClr val="EFF6FF"/>
+          </a:solidFill>
+          <a:ln w="9525">
+            <a:solidFill>
+              <a:srgbClr val="E2E8F0"/>
+            </a:solidFill>
+            <a:prstDash val="solid"/>
+          </a:ln>
+          <a:effectLst>
+            <a:outerShdw sx="100000" sy="100000" kx="0" ky="0" algn="bl" rotWithShape="0" blurRad="76200" dist="25400" dir="5400000">
+              <a:srgbClr val="1E293B">
+                <a:alpha val="8000"/>
+              </a:srgbClr>
+            </a:outerShdw>
+          </a:effectLst>
+        </p:spPr>
+      </p:sp>
+      <p:sp>
+        <p:nvSpPr>
+          <p:cNvPr id="5" name="Text 3"/>
+          <p:cNvSpPr txBox="1"/>
+          <p:nvPr/>
+        </p:nvSpPr>
+        <p:spPr>
+          <a:xfrm>
+            <a:off x="749808" y="1609344"/>
+            <a:ext cx="5038344" cy="320040"/>
+          </a:xfrm>
+          <a:prstGeom prst="rect">
+            <a:avLst/>
+          </a:prstGeom>
+          <a:noFill/>
+          <a:ln/>
+        </p:spPr>
+        <p:txBody>
+          <a:bodyPr wrap="square" lIns="0" tIns="0" rIns="0" bIns="0" rtlCol="0" anchor="ctr"/>
+          <a:lstStyle/>
+          <a:p>
+            <a:pPr algn="l" indent="0" marL="0">
+              <a:buNone/>
+            </a:pPr>
+            <a:r>
+              <a:rPr lang="en-US" sz="1300" b="1" dirty="0">
+                <a:solidFill>
+                  <a:srgbClr val="0F172A"/>
+                </a:solidFill>
+                <a:latin typeface="Microsoft JhengHei" pitchFamily="34" charset="0"/>
+                <a:ea typeface="Microsoft JhengHei" pitchFamily="34" charset="-122"/>
+                <a:cs typeface="Microsoft JhengHei" pitchFamily="34" charset="-120"/>
+              </a:rPr>
+              <a:t>怎麼做？（Covered-Call Wheel 概念）</a:t>
+            </a:r>
+            <a:endParaRPr lang="en-US" sz="1300" dirty="0"/>
+          </a:p>
+        </p:txBody>
+      </p:sp>
+      <p:sp>
+        <p:nvSpPr>
+          <p:cNvPr id="6" name="Text 4"/>
+          <p:cNvSpPr txBox="1"/>
+          <p:nvPr/>
+        </p:nvSpPr>
+        <p:spPr>
+          <a:xfrm>
+            <a:off x="749808" y="1965960"/>
+            <a:ext cx="5038344" cy="1261872"/>
+          </a:xfrm>
+          <a:prstGeom prst="rect">
+            <a:avLst/>
+          </a:prstGeom>
+          <a:noFill/>
+          <a:ln/>
+        </p:spPr>
+        <p:txBody>
+          <a:bodyPr wrap="square" lIns="0" tIns="0" rIns="0" bIns="0" rtlCol="0" anchor="t"/>
+          <a:lstStyle/>
+          <a:p>
+            <a:pPr algn="l" indent="0" marL="0">
+              <a:lnSpc>
+                <a:spcPct val="115000"/>
+              </a:lnSpc>
+              <a:buNone/>
+            </a:pPr>
+            <a:r>
+              <a:rPr lang="en-US" sz="1100" dirty="0">
+                <a:solidFill>
+                  <a:srgbClr val="334155"/>
+                </a:solidFill>
+                <a:latin typeface="Microsoft JhengHei" pitchFamily="34" charset="0"/>
+                <a:ea typeface="Microsoft JhengHei" pitchFamily="34" charset="-122"/>
+                <a:cs typeface="Microsoft JhengHei" pitchFamily="34" charset="-120"/>
+              </a:rPr>
+              <a:t>① 低買轉換為 BTC 後，② 立即以持有之 BTC、相同行使價（$55,900）掛出「高賣」收取權利金；③ 若到期未漲破，繼續持有 BTC 並重複掛單；④ 一旦漲破，BTC 依原行使價換回 USDT，本金名目值完整取回，且期間累積之權利金全數保留。</a:t>
+            </a:r>
+            <a:endParaRPr lang="en-US" sz="1100" dirty="0"/>
+          </a:p>
+        </p:txBody>
+      </p:sp>
+      <p:graphicFrame>
+        <p:nvGraphicFramePr>
+          <p:cNvPr id="11" name="Table 0"/>
+          <p:cNvGraphicFramePr>
+            <a:graphicFrameLocks noGrp="1"/>
+          </p:cNvGraphicFramePr>
+          <p:nvPr>
+            <p:extLst>
+              <p:ext uri="{D42A27DB-BD31-4B8C-83A1-F6EECF244321}">
+                <p14:modId xmlns:p14="http://schemas.microsoft.com/office/powerpoint/2010/main" val="1579011935"/>
+              </p:ext>
+            </p:extLst>
+          </p:nvPr>
+        </p:nvGraphicFramePr>
+        <p:xfrm>
+          <a:off x="6172200" y="1463040"/>
+          <a:ext cx="5468112" cy="914400"/>
+        </p:xfrm>
+        <a:graphic>
+          <a:graphicData uri="http://schemas.openxmlformats.org/drawingml/2006/table">
+            <a:tbl>
+              <a:tblPr/>
+              <a:tblGrid>
+                <a:gridCol w="1051560"/>
+                <a:gridCol w="1947672"/>
+                <a:gridCol w="914400"/>
+                <a:gridCol w="1005840"/>
+                <a:gridCol w="1463040"/>
+              </a:tblGrid>
+              <a:tr h="457200">
+                <a:tc>
+                  <a:txBody>
+                    <a:bodyPr/>
+                    <a:lstStyle/>
+                    <a:p>
+                      <a:pPr algn="ctr" indent="0" marL="0">
+                        <a:buNone/>
+                      </a:pPr>
+                      <a:r>
+                        <a:rPr lang="en-US" sz="900" b="1" dirty="0">
+                          <a:solidFill>
+                            <a:srgbClr val="FFFFFF"/>
+                          </a:solidFill>
+                        </a:rPr>
+                        <a:t>週期</a:t>
+                      </a:r>
+                      <a:endParaRPr lang="en-US" sz="900" dirty="0"/>
+                    </a:p>
+                  </a:txBody>
+                  <a:tcPr marL="73152" marR="73152" marT="45720" marB="45720" anchor="ctr">
+                    <a:lnL w="9525" cap="flat" cmpd="sng" algn="ctr">
+                      <a:solidFill>
+                        <a:srgbClr val="E2E8F0"/>
+                      </a:solidFill>
+                      <a:prstDash val="solid"/>
+                      <a:round/>
+                      <a:headEnd type="none" w="med" len="med"/>
+                      <a:tailEnd type="none" w="med" len="med"/>
+                    </a:lnL>
+                    <a:lnR w="9525" cap="flat" cmpd="sng" algn="ctr">
+                      <a:solidFill>
+                        <a:srgbClr val="E2E8F0"/>
+                      </a:solidFill>
+                      <a:prstDash val="solid"/>
+                      <a:round/>
+                      <a:headEnd type="none" w="med" len="med"/>
+                      <a:tailEnd type="none" w="med" len="med"/>
+                    </a:lnR>
+                    <a:lnT w="9525" cap="flat" cmpd="sng" algn="ctr">
+                      <a:solidFill>
+                        <a:srgbClr val="E2E8F0"/>
+                      </a:solidFill>
+                      <a:prstDash val="solid"/>
+                      <a:round/>
+                      <a:headEnd type="none" w="med" len="med"/>
+                      <a:tailEnd type="none" w="med" len="med"/>
+                    </a:lnT>
+                    <a:lnB w="9525" cap="flat" cmpd="sng" algn="ctr">
+                      <a:solidFill>
+                        <a:srgbClr val="E2E8F0"/>
+                      </a:solidFill>
+                      <a:prstDash val="solid"/>
+                      <a:round/>
+                      <a:headEnd type="none" w="med" len="med"/>
+                      <a:tailEnd type="none" w="med" len="med"/>
+                    </a:lnB>
+                    <a:solidFill>
+                      <a:srgbClr val="0F172A"/>
+                    </a:solidFill>
+                  </a:tcPr>
+                </a:tc>
+                <a:tc>
+                  <a:txBody>
+                    <a:bodyPr/>
+                    <a:lstStyle/>
+                    <a:p>
+                      <a:pPr algn="ctr" indent="0" marL="0">
+                        <a:buNone/>
+                      </a:pPr>
+                      <a:r>
+                        <a:rPr lang="en-US" sz="900" b="1" dirty="0">
+                          <a:solidFill>
+                            <a:srgbClr val="FFFFFF"/>
+                          </a:solidFill>
+                        </a:rPr>
+                        <a:t>操作</a:t>
+                      </a:r>
+                      <a:endParaRPr lang="en-US" sz="900" dirty="0"/>
+                    </a:p>
+                  </a:txBody>
+                  <a:tcPr marL="73152" marR="73152" marT="45720" marB="45720" anchor="ctr">
+                    <a:lnL w="9525" cap="flat" cmpd="sng" algn="ctr">
+                      <a:solidFill>
+                        <a:srgbClr val="E2E8F0"/>
+                      </a:solidFill>
+                      <a:prstDash val="solid"/>
+                      <a:round/>
+                      <a:headEnd type="none" w="med" len="med"/>
+                      <a:tailEnd type="none" w="med" len="med"/>
+                    </a:lnL>
+                    <a:lnR w="9525" cap="flat" cmpd="sng" algn="ctr">
+                      <a:solidFill>
+                        <a:srgbClr val="E2E8F0"/>
+                      </a:solidFill>
+                      <a:prstDash val="solid"/>
+                      <a:round/>
+                      <a:headEnd type="none" w="med" len="med"/>
+                      <a:tailEnd type="none" w="med" len="med"/>
+                    </a:lnR>
+                    <a:lnT w="9525" cap="flat" cmpd="sng" algn="ctr">
+                      <a:solidFill>
+                        <a:srgbClr val="E2E8F0"/>
+                      </a:solidFill>
+                      <a:prstDash val="solid"/>
+                      <a:round/>
+                      <a:headEnd type="none" w="med" len="med"/>
+                      <a:tailEnd type="none" w="med" len="med"/>
+                    </a:lnT>
+                    <a:lnB w="9525" cap="flat" cmpd="sng" algn="ctr">
+                      <a:solidFill>
+                        <a:srgbClr val="E2E8F0"/>
+                      </a:solidFill>
+                      <a:prstDash val="solid"/>
+                      <a:round/>
+                      <a:headEnd type="none" w="med" len="med"/>
+                      <a:tailEnd type="none" w="med" len="med"/>
+                    </a:lnB>
+                    <a:solidFill>
+                      <a:srgbClr val="0F172A"/>
+                    </a:solidFill>
+                  </a:tcPr>
+                </a:tc>
+                <a:tc>
+                  <a:txBody>
+                    <a:bodyPr/>
+                    <a:lstStyle/>
+                    <a:p>
+                      <a:pPr algn="ctr" indent="0" marL="0">
+                        <a:buNone/>
+                      </a:pPr>
+                      <a:r>
+                        <a:rPr lang="en-US" sz="900" b="1" dirty="0">
+                          <a:solidFill>
+                            <a:srgbClr val="FFFFFF"/>
+                          </a:solidFill>
+                        </a:rPr>
+                        <a:t>示意年化</a:t>
+                      </a:r>
+                      <a:endParaRPr lang="en-US" sz="900" dirty="0"/>
+                    </a:p>
+                  </a:txBody>
+                  <a:tcPr marL="73152" marR="73152" marT="45720" marB="45720" anchor="ctr">
+                    <a:lnL w="9525" cap="flat" cmpd="sng" algn="ctr">
+                      <a:solidFill>
+                        <a:srgbClr val="E2E8F0"/>
+                      </a:solidFill>
+                      <a:prstDash val="solid"/>
+                      <a:round/>
+                      <a:headEnd type="none" w="med" len="med"/>
+                      <a:tailEnd type="none" w="med" len="med"/>
+                    </a:lnL>
+                    <a:lnR w="9525" cap="flat" cmpd="sng" algn="ctr">
+                      <a:solidFill>
+                        <a:srgbClr val="E2E8F0"/>
+                      </a:solidFill>
+                      <a:prstDash val="solid"/>
+                      <a:round/>
+                      <a:headEnd type="none" w="med" len="med"/>
+                      <a:tailEnd type="none" w="med" len="med"/>
+                    </a:lnR>
+                    <a:lnT w="9525" cap="flat" cmpd="sng" algn="ctr">
+                      <a:solidFill>
+                        <a:srgbClr val="E2E8F0"/>
+                      </a:solidFill>
+                      <a:prstDash val="solid"/>
+                      <a:round/>
+                      <a:headEnd type="none" w="med" len="med"/>
+                      <a:tailEnd type="none" w="med" len="med"/>
+                    </a:lnT>
+                    <a:lnB w="9525" cap="flat" cmpd="sng" algn="ctr">
+                      <a:solidFill>
+                        <a:srgbClr val="E2E8F0"/>
+                      </a:solidFill>
+                      <a:prstDash val="solid"/>
+                      <a:round/>
+                      <a:headEnd type="none" w="med" len="med"/>
+                      <a:tailEnd type="none" w="med" len="med"/>
+                    </a:lnB>
+                    <a:solidFill>
+                      <a:srgbClr val="0F172A"/>
+                    </a:solidFill>
+                  </a:tcPr>
+                </a:tc>
+                <a:tc>
+                  <a:txBody>
+                    <a:bodyPr/>
+                    <a:lstStyle/>
+                    <a:p>
+                      <a:pPr algn="ctr" indent="0" marL="0">
+                        <a:buNone/>
+                      </a:pPr>
+                      <a:r>
+                        <a:rPr lang="en-US" sz="900" b="1" dirty="0">
+                          <a:solidFill>
+                            <a:srgbClr val="FFFFFF"/>
+                          </a:solidFill>
+                        </a:rPr>
+                        <a:t>本期權利金</a:t>
+                      </a:r>
+                      <a:endParaRPr lang="en-US" sz="900" dirty="0"/>
+                    </a:p>
+                  </a:txBody>
+                  <a:tcPr marL="73152" marR="73152" marT="45720" marB="45720" anchor="ctr">
+                    <a:lnL w="9525" cap="flat" cmpd="sng" algn="ctr">
+                      <a:solidFill>
+                        <a:srgbClr val="E2E8F0"/>
+                      </a:solidFill>
+                      <a:prstDash val="solid"/>
+                      <a:round/>
+                      <a:headEnd type="none" w="med" len="med"/>
+                      <a:tailEnd type="none" w="med" len="med"/>
+                    </a:lnL>
+                    <a:lnR w="9525" cap="flat" cmpd="sng" algn="ctr">
+                      <a:solidFill>
+                        <a:srgbClr val="E2E8F0"/>
+                      </a:solidFill>
+                      <a:prstDash val="solid"/>
+                      <a:round/>
+                      <a:headEnd type="none" w="med" len="med"/>
+                      <a:tailEnd type="none" w="med" len="med"/>
+                    </a:lnR>
+                    <a:lnT w="9525" cap="flat" cmpd="sng" algn="ctr">
+                      <a:solidFill>
+                        <a:srgbClr val="E2E8F0"/>
+                      </a:solidFill>
+                      <a:prstDash val="solid"/>
+                      <a:round/>
+                      <a:headEnd type="none" w="med" len="med"/>
+                      <a:tailEnd type="none" w="med" len="med"/>
+                    </a:lnT>
+                    <a:lnB w="9525" cap="flat" cmpd="sng" algn="ctr">
+                      <a:solidFill>
+                        <a:srgbClr val="E2E8F0"/>
+                      </a:solidFill>
+                      <a:prstDash val="solid"/>
+                      <a:round/>
+                      <a:headEnd type="none" w="med" len="med"/>
+                      <a:tailEnd type="none" w="med" len="med"/>
+                    </a:lnB>
+                    <a:solidFill>
+                      <a:srgbClr val="0F172A"/>
+                    </a:solidFill>
+                  </a:tcPr>
+                </a:tc>
+                <a:tc>
+                  <a:txBody>
+                    <a:bodyPr/>
+                    <a:lstStyle/>
+                    <a:p>
+                      <a:pPr algn="ctr" indent="0" marL="0">
+                        <a:buNone/>
+                      </a:pPr>
+                      <a:r>
+                        <a:rPr lang="en-US" sz="900" b="1" dirty="0">
+                          <a:solidFill>
+                            <a:srgbClr val="FFFFFF"/>
+                          </a:solidFill>
+                        </a:rPr>
+                        <a:t>結算結果</a:t>
+                      </a:r>
+                      <a:endParaRPr lang="en-US" sz="900" dirty="0"/>
+                    </a:p>
+                  </a:txBody>
+                  <a:tcPr marL="73152" marR="73152" marT="45720" marB="45720" anchor="ctr">
+                    <a:lnL w="9525" cap="flat" cmpd="sng" algn="ctr">
+                      <a:solidFill>
+                        <a:srgbClr val="E2E8F0"/>
+                      </a:solidFill>
+                      <a:prstDash val="solid"/>
+                      <a:round/>
+                      <a:headEnd type="none" w="med" len="med"/>
+                      <a:tailEnd type="none" w="med" len="med"/>
+                    </a:lnL>
+                    <a:lnR w="9525" cap="flat" cmpd="sng" algn="ctr">
+                      <a:solidFill>
+                        <a:srgbClr val="E2E8F0"/>
+                      </a:solidFill>
+                      <a:prstDash val="solid"/>
+                      <a:round/>
+                      <a:headEnd type="none" w="med" len="med"/>
+                      <a:tailEnd type="none" w="med" len="med"/>
+                    </a:lnR>
+                    <a:lnT w="9525" cap="flat" cmpd="sng" algn="ctr">
+                      <a:solidFill>
+                        <a:srgbClr val="E2E8F0"/>
+                      </a:solidFill>
+                      <a:prstDash val="solid"/>
+                      <a:round/>
+                      <a:headEnd type="none" w="med" len="med"/>
+                      <a:tailEnd type="none" w="med" len="med"/>
+                    </a:lnT>
+                    <a:lnB w="9525" cap="flat" cmpd="sng" algn="ctr">
+                      <a:solidFill>
+                        <a:srgbClr val="E2E8F0"/>
+                      </a:solidFill>
+                      <a:prstDash val="solid"/>
+                      <a:round/>
+                      <a:headEnd type="none" w="med" len="med"/>
+                      <a:tailEnd type="none" w="med" len="med"/>
+                    </a:lnB>
+                    <a:solidFill>
+                      <a:srgbClr val="0F172A"/>
+                    </a:solidFill>
+                  </a:tcPr>
+                </a:tc>
+              </a:tr>
+              <a:tr h="457200">
+                <a:tc>
+                  <a:txBody>
+                    <a:bodyPr/>
+                    <a:lstStyle/>
+                    <a:p>
+                      <a:pPr algn="l" indent="0" marL="0">
+                        <a:buNone/>
+                      </a:pPr>
+                      <a:r>
+                        <a:rPr lang="en-US" sz="900" dirty="0">
+                          <a:solidFill>
+                            <a:srgbClr val="334155"/>
+                          </a:solidFill>
+                        </a:rPr>
+                        <a:t>第1週 低買</a:t>
+                      </a:r>
+                      <a:endParaRPr lang="en-US" sz="900" dirty="0"/>
+                    </a:p>
+                  </a:txBody>
+                  <a:tcPr marL="73152" marR="73152" marT="45720" marB="45720" anchor="ctr">
+                    <a:lnL w="9525" cap="flat" cmpd="sng" algn="ctr">
+                      <a:solidFill>
+                        <a:srgbClr val="E2E8F0"/>
+                      </a:solidFill>
+                      <a:prstDash val="solid"/>
+                      <a:round/>
+                      <a:headEnd type="none" w="med" len="med"/>
+                      <a:tailEnd type="none" w="med" len="med"/>
+                    </a:lnL>
+                    <a:lnR w="9525" cap="flat" cmpd="sng" algn="ctr">
+                      <a:solidFill>
+                        <a:srgbClr val="E2E8F0"/>
+                      </a:solidFill>
+                      <a:prstDash val="solid"/>
+                      <a:round/>
+                      <a:headEnd type="none" w="med" len="med"/>
+                      <a:tailEnd type="none" w="med" len="med"/>
+                    </a:lnR>
+                    <a:lnT w="9525" cap="flat" cmpd="sng" algn="ctr">
+                      <a:solidFill>
+                        <a:srgbClr val="E2E8F0"/>
+                      </a:solidFill>
+                      <a:prstDash val="solid"/>
+                      <a:round/>
+                      <a:headEnd type="none" w="med" len="med"/>
+                      <a:tailEnd type="none" w="med" len="med"/>
+                    </a:lnT>
+                    <a:lnB w="9525" cap="flat" cmpd="sng" algn="ctr">
+                      <a:solidFill>
+                        <a:srgbClr val="E2E8F0"/>
+                      </a:solidFill>
+                      <a:prstDash val="solid"/>
+                      <a:round/>
+                      <a:headEnd type="none" w="med" len="med"/>
+                      <a:tailEnd type="none" w="med" len="med"/>
+                    </a:lnB>
+                    <a:solidFill>
+                      <a:srgbClr val="FFFFFF"/>
+                    </a:solidFill>
+                  </a:tcPr>
+                </a:tc>
+                <a:tc>
+                  <a:txBody>
+                    <a:bodyPr/>
+                    <a:lstStyle/>
+                    <a:p>
+                      <a:pPr algn="l" indent="0" marL="0">
+                        <a:buNone/>
+                      </a:pPr>
+                      <a:r>
+                        <a:rPr lang="en-US" sz="900" dirty="0">
+                          <a:solidFill>
+                            <a:srgbClr val="334155"/>
+                          </a:solidFill>
+                        </a:rPr>
+                        <a:t>$1,000,000→轉換為17.8891 BTC</a:t>
+                      </a:r>
+                      <a:endParaRPr lang="en-US" sz="900" dirty="0"/>
+                    </a:p>
+                  </a:txBody>
+                  <a:tcPr marL="73152" marR="73152" marT="45720" marB="45720" anchor="ctr">
+                    <a:lnL w="9525" cap="flat" cmpd="sng" algn="ctr">
+                      <a:solidFill>
+                        <a:srgbClr val="E2E8F0"/>
+                      </a:solidFill>
+                      <a:prstDash val="solid"/>
+                      <a:round/>
+                      <a:headEnd type="none" w="med" len="med"/>
+                      <a:tailEnd type="none" w="med" len="med"/>
+                    </a:lnL>
+                    <a:lnR w="9525" cap="flat" cmpd="sng" algn="ctr">
+                      <a:solidFill>
+                        <a:srgbClr val="E2E8F0"/>
+                      </a:solidFill>
+                      <a:prstDash val="solid"/>
+                      <a:round/>
+                      <a:headEnd type="none" w="med" len="med"/>
+                      <a:tailEnd type="none" w="med" len="med"/>
+                    </a:lnR>
+                    <a:lnT w="9525" cap="flat" cmpd="sng" algn="ctr">
+                      <a:solidFill>
+                        <a:srgbClr val="E2E8F0"/>
+                      </a:solidFill>
+                      <a:prstDash val="solid"/>
+                      <a:round/>
+                      <a:headEnd type="none" w="med" len="med"/>
+                      <a:tailEnd type="none" w="med" len="med"/>
+                    </a:lnT>
+                    <a:lnB w="9525" cap="flat" cmpd="sng" algn="ctr">
+                      <a:solidFill>
+                        <a:srgbClr val="E2E8F0"/>
+                      </a:solidFill>
+                      <a:prstDash val="solid"/>
+                      <a:round/>
+                      <a:headEnd type="none" w="med" len="med"/>
+                      <a:tailEnd type="none" w="med" len="med"/>
+                    </a:lnB>
+                    <a:solidFill>
+                      <a:srgbClr val="FFFFFF"/>
+                    </a:solidFill>
+                  </a:tcPr>
+                </a:tc>
+                <a:tc>
+                  <a:txBody>
+                    <a:bodyPr/>
+                    <a:lstStyle/>
+                    <a:p>
+                      <a:pPr algn="l" indent="0" marL="0">
+                        <a:buNone/>
+                      </a:pPr>
+                      <a:r>
+                        <a:rPr lang="en-US" sz="900" dirty="0">
+                          <a:solidFill>
+                            <a:srgbClr val="334155"/>
+                          </a:solidFill>
+                        </a:rPr>
+                        <a:t>40%</a:t>
+                      </a:r>
+                      <a:endParaRPr lang="en-US" sz="900" dirty="0"/>
+                    </a:p>
+                  </a:txBody>
+                  <a:tcPr marL="73152" marR="73152" marT="45720" marB="45720" anchor="ctr">
+                    <a:lnL w="9525" cap="flat" cmpd="sng" algn="ctr">
+                      <a:solidFill>
+                        <a:srgbClr val="E2E8F0"/>
+                      </a:solidFill>
+                      <a:prstDash val="solid"/>
+                      <a:round/>
+                      <a:headEnd type="none" w="med" len="med"/>
+                      <a:tailEnd type="none" w="med" len="med"/>
+                    </a:lnL>
+                    <a:lnR w="9525" cap="flat" cmpd="sng" algn="ctr">
+                      <a:solidFill>
+                        <a:srgbClr val="E2E8F0"/>
+                      </a:solidFill>
+                      <a:prstDash val="solid"/>
+                      <a:round/>
+                      <a:headEnd type="none" w="med" len="med"/>
+                      <a:tailEnd type="none" w="med" len="med"/>
+                    </a:lnR>
+                    <a:lnT w="9525" cap="flat" cmpd="sng" algn="ctr">
+                      <a:solidFill>
+                        <a:srgbClr val="E2E8F0"/>
+                      </a:solidFill>
+                      <a:prstDash val="solid"/>
+                      <a:round/>
+                      <a:headEnd type="none" w="med" len="med"/>
+                      <a:tailEnd type="none" w="med" len="med"/>
+                    </a:lnT>
+                    <a:lnB w="9525" cap="flat" cmpd="sng" algn="ctr">
+                      <a:solidFill>
+                        <a:srgbClr val="E2E8F0"/>
+                      </a:solidFill>
+                      <a:prstDash val="solid"/>
+                      <a:round/>
+                      <a:headEnd type="none" w="med" len="med"/>
+                      <a:tailEnd type="none" w="med" len="med"/>
+                    </a:lnB>
+                    <a:solidFill>
+                      <a:srgbClr val="FFFFFF"/>
+                    </a:solidFill>
+                  </a:tcPr>
+                </a:tc>
+                <a:tc>
+                  <a:txBody>
+                    <a:bodyPr/>
+                    <a:lstStyle/>
+                    <a:p>
+                      <a:pPr algn="l" indent="0" marL="0">
+                        <a:buNone/>
+                      </a:pPr>
+                      <a:r>
+                        <a:rPr lang="en-US" sz="900" dirty="0">
+                          <a:solidFill>
+                            <a:srgbClr val="334155"/>
+                          </a:solidFill>
+                        </a:rPr>
+                        <a:t>$7,671</a:t>
+                      </a:r>
+                      <a:endParaRPr lang="en-US" sz="900" dirty="0"/>
+                    </a:p>
+                  </a:txBody>
+                  <a:tcPr marL="73152" marR="73152" marT="45720" marB="45720" anchor="ctr">
+                    <a:lnL w="9525" cap="flat" cmpd="sng" algn="ctr">
+                      <a:solidFill>
+                        <a:srgbClr val="E2E8F0"/>
+                      </a:solidFill>
+                      <a:prstDash val="solid"/>
+                      <a:round/>
+                      <a:headEnd type="none" w="med" len="med"/>
+                      <a:tailEnd type="none" w="med" len="med"/>
+                    </a:lnL>
+                    <a:lnR w="9525" cap="flat" cmpd="sng" algn="ctr">
+                      <a:solidFill>
+                        <a:srgbClr val="E2E8F0"/>
+                      </a:solidFill>
+                      <a:prstDash val="solid"/>
+                      <a:round/>
+                      <a:headEnd type="none" w="med" len="med"/>
+                      <a:tailEnd type="none" w="med" len="med"/>
+                    </a:lnR>
+                    <a:lnT w="9525" cap="flat" cmpd="sng" algn="ctr">
+                      <a:solidFill>
+                        <a:srgbClr val="E2E8F0"/>
+                      </a:solidFill>
+                      <a:prstDash val="solid"/>
+                      <a:round/>
+                      <a:headEnd type="none" w="med" len="med"/>
+                      <a:tailEnd type="none" w="med" len="med"/>
+                    </a:lnT>
+                    <a:lnB w="9525" cap="flat" cmpd="sng" algn="ctr">
+                      <a:solidFill>
+                        <a:srgbClr val="E2E8F0"/>
+                      </a:solidFill>
+                      <a:prstDash val="solid"/>
+                      <a:round/>
+                      <a:headEnd type="none" w="med" len="med"/>
+                      <a:tailEnd type="none" w="med" len="med"/>
+                    </a:lnB>
+                    <a:solidFill>
+                      <a:srgbClr val="FFFFFF"/>
+                    </a:solidFill>
+                  </a:tcPr>
+                </a:tc>
+                <a:tc>
+                  <a:txBody>
+                    <a:bodyPr/>
+                    <a:lstStyle/>
+                    <a:p>
+                      <a:pPr algn="l" indent="0" marL="0">
+                        <a:buNone/>
+                      </a:pPr>
+                      <a:r>
+                        <a:rPr lang="en-US" sz="900" dirty="0">
+                          <a:solidFill>
+                            <a:srgbClr val="334155"/>
+                          </a:solidFill>
+                        </a:rPr>
+                        <a:t>跌破，轉換為BTC</a:t>
+                      </a:r>
+                      <a:endParaRPr lang="en-US" sz="900" dirty="0"/>
+                    </a:p>
+                  </a:txBody>
+                  <a:tcPr marL="73152" marR="73152" marT="45720" marB="45720" anchor="ctr">
+                    <a:lnL w="9525" cap="flat" cmpd="sng" algn="ctr">
+                      <a:solidFill>
+                        <a:srgbClr val="E2E8F0"/>
+                      </a:solidFill>
+                      <a:prstDash val="solid"/>
+                      <a:round/>
+                      <a:headEnd type="none" w="med" len="med"/>
+                      <a:tailEnd type="none" w="med" len="med"/>
+                    </a:lnL>
+                    <a:lnR w="9525" cap="flat" cmpd="sng" algn="ctr">
+                      <a:solidFill>
+                        <a:srgbClr val="E2E8F0"/>
+                      </a:solidFill>
+                      <a:prstDash val="solid"/>
+                      <a:round/>
+                      <a:headEnd type="none" w="med" len="med"/>
+                      <a:tailEnd type="none" w="med" len="med"/>
+                    </a:lnR>
+                    <a:lnT w="9525" cap="flat" cmpd="sng" algn="ctr">
+                      <a:solidFill>
+                        <a:srgbClr val="E2E8F0"/>
+                      </a:solidFill>
+                      <a:prstDash val="solid"/>
+                      <a:round/>
+                      <a:headEnd type="none" w="med" len="med"/>
+                      <a:tailEnd type="none" w="med" len="med"/>
+                    </a:lnT>
+                    <a:lnB w="9525" cap="flat" cmpd="sng" algn="ctr">
+                      <a:solidFill>
+                        <a:srgbClr val="E2E8F0"/>
+                      </a:solidFill>
+                      <a:prstDash val="solid"/>
+                      <a:round/>
+                      <a:headEnd type="none" w="med" len="med"/>
+                      <a:tailEnd type="none" w="med" len="med"/>
+                    </a:lnB>
+                    <a:solidFill>
+                      <a:srgbClr val="FFFFFF"/>
+                    </a:solidFill>
+                  </a:tcPr>
+                </a:tc>
+              </a:tr>
+              <a:tr h="457200">
+                <a:tc>
+                  <a:txBody>
+                    <a:bodyPr/>
+                    <a:lstStyle/>
+                    <a:p>
+                      <a:pPr algn="l" indent="0" marL="0">
+                        <a:buNone/>
+                      </a:pPr>
+                      <a:r>
+                        <a:rPr lang="en-US" sz="900" dirty="0">
+                          <a:solidFill>
+                            <a:srgbClr val="334155"/>
+                          </a:solidFill>
+                        </a:rPr>
+                        <a:t>第2週 高賣</a:t>
+                      </a:r>
+                      <a:endParaRPr lang="en-US" sz="900" dirty="0"/>
+                    </a:p>
+                  </a:txBody>
+                  <a:tcPr marL="73152" marR="73152" marT="45720" marB="45720" anchor="ctr">
+                    <a:lnL w="9525" cap="flat" cmpd="sng" algn="ctr">
+                      <a:solidFill>
+                        <a:srgbClr val="E2E8F0"/>
+                      </a:solidFill>
+                      <a:prstDash val="solid"/>
+                      <a:round/>
+                      <a:headEnd type="none" w="med" len="med"/>
+                      <a:tailEnd type="none" w="med" len="med"/>
+                    </a:lnL>
+                    <a:lnR w="9525" cap="flat" cmpd="sng" algn="ctr">
+                      <a:solidFill>
+                        <a:srgbClr val="E2E8F0"/>
+                      </a:solidFill>
+                      <a:prstDash val="solid"/>
+                      <a:round/>
+                      <a:headEnd type="none" w="med" len="med"/>
+                      <a:tailEnd type="none" w="med" len="med"/>
+                    </a:lnR>
+                    <a:lnT w="9525" cap="flat" cmpd="sng" algn="ctr">
+                      <a:solidFill>
+                        <a:srgbClr val="E2E8F0"/>
+                      </a:solidFill>
+                      <a:prstDash val="solid"/>
+                      <a:round/>
+                      <a:headEnd type="none" w="med" len="med"/>
+                      <a:tailEnd type="none" w="med" len="med"/>
+                    </a:lnT>
+                    <a:lnB w="9525" cap="flat" cmpd="sng" algn="ctr">
+                      <a:solidFill>
+                        <a:srgbClr val="E2E8F0"/>
+                      </a:solidFill>
+                      <a:prstDash val="solid"/>
+                      <a:round/>
+                      <a:headEnd type="none" w="med" len="med"/>
+                      <a:tailEnd type="none" w="med" len="med"/>
+                    </a:lnB>
+                    <a:solidFill>
+                      <a:srgbClr val="F8FAFC"/>
+                    </a:solidFill>
+                  </a:tcPr>
+                </a:tc>
+                <a:tc>
+                  <a:txBody>
+                    <a:bodyPr/>
+                    <a:lstStyle/>
+                    <a:p>
+                      <a:pPr algn="l" indent="0" marL="0">
+                        <a:buNone/>
+                      </a:pPr>
+                      <a:r>
+                        <a:rPr lang="en-US" sz="900" dirty="0">
+                          <a:solidFill>
+                            <a:srgbClr val="334155"/>
+                          </a:solidFill>
+                        </a:rPr>
+                        <a:t>同一行使價 $55,900 滾動掛單</a:t>
+                      </a:r>
+                      <a:endParaRPr lang="en-US" sz="900" dirty="0"/>
+                    </a:p>
+                  </a:txBody>
+                  <a:tcPr marL="73152" marR="73152" marT="45720" marB="45720" anchor="ctr">
+                    <a:lnL w="9525" cap="flat" cmpd="sng" algn="ctr">
+                      <a:solidFill>
+                        <a:srgbClr val="E2E8F0"/>
+                      </a:solidFill>
+                      <a:prstDash val="solid"/>
+                      <a:round/>
+                      <a:headEnd type="none" w="med" len="med"/>
+                      <a:tailEnd type="none" w="med" len="med"/>
+                    </a:lnL>
+                    <a:lnR w="9525" cap="flat" cmpd="sng" algn="ctr">
+                      <a:solidFill>
+                        <a:srgbClr val="E2E8F0"/>
+                      </a:solidFill>
+                      <a:prstDash val="solid"/>
+                      <a:round/>
+                      <a:headEnd type="none" w="med" len="med"/>
+                      <a:tailEnd type="none" w="med" len="med"/>
+                    </a:lnR>
+                    <a:lnT w="9525" cap="flat" cmpd="sng" algn="ctr">
+                      <a:solidFill>
+                        <a:srgbClr val="E2E8F0"/>
+                      </a:solidFill>
+                      <a:prstDash val="solid"/>
+                      <a:round/>
+                      <a:headEnd type="none" w="med" len="med"/>
+                      <a:tailEnd type="none" w="med" len="med"/>
+                    </a:lnT>
+                    <a:lnB w="9525" cap="flat" cmpd="sng" algn="ctr">
+                      <a:solidFill>
+                        <a:srgbClr val="E2E8F0"/>
+                      </a:solidFill>
+                      <a:prstDash val="solid"/>
+                      <a:round/>
+                      <a:headEnd type="none" w="med" len="med"/>
+                      <a:tailEnd type="none" w="med" len="med"/>
+                    </a:lnB>
+                    <a:solidFill>
+                      <a:srgbClr val="F8FAFC"/>
+                    </a:solidFill>
+                  </a:tcPr>
+                </a:tc>
+                <a:tc>
+                  <a:txBody>
+                    <a:bodyPr/>
+                    <a:lstStyle/>
+                    <a:p>
+                      <a:pPr algn="l" indent="0" marL="0">
+                        <a:buNone/>
+                      </a:pPr>
+                      <a:r>
+                        <a:rPr lang="en-US" sz="900" dirty="0">
+                          <a:solidFill>
+                            <a:srgbClr val="334155"/>
+                          </a:solidFill>
+                        </a:rPr>
+                        <a:t>32%</a:t>
+                      </a:r>
+                      <a:endParaRPr lang="en-US" sz="900" dirty="0"/>
+                    </a:p>
+                  </a:txBody>
+                  <a:tcPr marL="73152" marR="73152" marT="45720" marB="45720" anchor="ctr">
+                    <a:lnL w="9525" cap="flat" cmpd="sng" algn="ctr">
+                      <a:solidFill>
+                        <a:srgbClr val="E2E8F0"/>
+                      </a:solidFill>
+                      <a:prstDash val="solid"/>
+                      <a:round/>
+                      <a:headEnd type="none" w="med" len="med"/>
+                      <a:tailEnd type="none" w="med" len="med"/>
+                    </a:lnL>
+                    <a:lnR w="9525" cap="flat" cmpd="sng" algn="ctr">
+                      <a:solidFill>
+                        <a:srgbClr val="E2E8F0"/>
+                      </a:solidFill>
+                      <a:prstDash val="solid"/>
+                      <a:round/>
+                      <a:headEnd type="none" w="med" len="med"/>
+                      <a:tailEnd type="none" w="med" len="med"/>
+                    </a:lnR>
+                    <a:lnT w="9525" cap="flat" cmpd="sng" algn="ctr">
+                      <a:solidFill>
+                        <a:srgbClr val="E2E8F0"/>
+                      </a:solidFill>
+                      <a:prstDash val="solid"/>
+                      <a:round/>
+                      <a:headEnd type="none" w="med" len="med"/>
+                      <a:tailEnd type="none" w="med" len="med"/>
+                    </a:lnT>
+                    <a:lnB w="9525" cap="flat" cmpd="sng" algn="ctr">
+                      <a:solidFill>
+                        <a:srgbClr val="E2E8F0"/>
+                      </a:solidFill>
+                      <a:prstDash val="solid"/>
+                      <a:round/>
+                      <a:headEnd type="none" w="med" len="med"/>
+                      <a:tailEnd type="none" w="med" len="med"/>
+                    </a:lnB>
+                    <a:solidFill>
+                      <a:srgbClr val="F8FAFC"/>
+                    </a:solidFill>
+                  </a:tcPr>
+                </a:tc>
+                <a:tc>
+                  <a:txBody>
+                    <a:bodyPr/>
+                    <a:lstStyle/>
+                    <a:p>
+                      <a:pPr algn="l" indent="0" marL="0">
+                        <a:buNone/>
+                      </a:pPr>
+                      <a:r>
+                        <a:rPr lang="en-US" sz="900" dirty="0">
+                          <a:solidFill>
+                            <a:srgbClr val="334155"/>
+                          </a:solidFill>
+                        </a:rPr>
+                        <a:t>$5,823</a:t>
+                      </a:r>
+                      <a:endParaRPr lang="en-US" sz="900" dirty="0"/>
+                    </a:p>
+                  </a:txBody>
+                  <a:tcPr marL="73152" marR="73152" marT="45720" marB="45720" anchor="ctr">
+                    <a:lnL w="9525" cap="flat" cmpd="sng" algn="ctr">
+                      <a:solidFill>
+                        <a:srgbClr val="E2E8F0"/>
+                      </a:solidFill>
+                      <a:prstDash val="solid"/>
+                      <a:round/>
+                      <a:headEnd type="none" w="med" len="med"/>
+                      <a:tailEnd type="none" w="med" len="med"/>
+                    </a:lnL>
+                    <a:lnR w="9525" cap="flat" cmpd="sng" algn="ctr">
+                      <a:solidFill>
+                        <a:srgbClr val="E2E8F0"/>
+                      </a:solidFill>
+                      <a:prstDash val="solid"/>
+                      <a:round/>
+                      <a:headEnd type="none" w="med" len="med"/>
+                      <a:tailEnd type="none" w="med" len="med"/>
+                    </a:lnR>
+                    <a:lnT w="9525" cap="flat" cmpd="sng" algn="ctr">
+                      <a:solidFill>
+                        <a:srgbClr val="E2E8F0"/>
+                      </a:solidFill>
+                      <a:prstDash val="solid"/>
+                      <a:round/>
+                      <a:headEnd type="none" w="med" len="med"/>
+                      <a:tailEnd type="none" w="med" len="med"/>
+                    </a:lnT>
+                    <a:lnB w="9525" cap="flat" cmpd="sng" algn="ctr">
+                      <a:solidFill>
+                        <a:srgbClr val="E2E8F0"/>
+                      </a:solidFill>
+                      <a:prstDash val="solid"/>
+                      <a:round/>
+                      <a:headEnd type="none" w="med" len="med"/>
+                      <a:tailEnd type="none" w="med" len="med"/>
+                    </a:lnB>
+                    <a:solidFill>
+                      <a:srgbClr val="F8FAFC"/>
+                    </a:solidFill>
+                  </a:tcPr>
+                </a:tc>
+                <a:tc>
+                  <a:txBody>
+                    <a:bodyPr/>
+                    <a:lstStyle/>
+                    <a:p>
+                      <a:pPr algn="l" indent="0" marL="0">
+                        <a:buNone/>
+                      </a:pPr>
+                      <a:r>
+                        <a:rPr lang="en-US" sz="900" dirty="0">
+                          <a:solidFill>
+                            <a:srgbClr val="334155"/>
+                          </a:solidFill>
+                        </a:rPr>
+                        <a:t>未漲破，續留BTC</a:t>
+                      </a:r>
+                      <a:endParaRPr lang="en-US" sz="900" dirty="0"/>
+                    </a:p>
+                  </a:txBody>
+                  <a:tcPr marL="73152" marR="73152" marT="45720" marB="45720" anchor="ctr">
+                    <a:lnL w="9525" cap="flat" cmpd="sng" algn="ctr">
+                      <a:solidFill>
+                        <a:srgbClr val="E2E8F0"/>
+                      </a:solidFill>
+                      <a:prstDash val="solid"/>
+                      <a:round/>
+                      <a:headEnd type="none" w="med" len="med"/>
+                      <a:tailEnd type="none" w="med" len="med"/>
+                    </a:lnL>
+                    <a:lnR w="9525" cap="flat" cmpd="sng" algn="ctr">
+                      <a:solidFill>
+                        <a:srgbClr val="E2E8F0"/>
+                      </a:solidFill>
+                      <a:prstDash val="solid"/>
+                      <a:round/>
+                      <a:headEnd type="none" w="med" len="med"/>
+                      <a:tailEnd type="none" w="med" len="med"/>
+                    </a:lnR>
+                    <a:lnT w="9525" cap="flat" cmpd="sng" algn="ctr">
+                      <a:solidFill>
+                        <a:srgbClr val="E2E8F0"/>
+                      </a:solidFill>
+                      <a:prstDash val="solid"/>
+                      <a:round/>
+                      <a:headEnd type="none" w="med" len="med"/>
+                      <a:tailEnd type="none" w="med" len="med"/>
+                    </a:lnT>
+                    <a:lnB w="9525" cap="flat" cmpd="sng" algn="ctr">
+                      <a:solidFill>
+                        <a:srgbClr val="E2E8F0"/>
+                      </a:solidFill>
+                      <a:prstDash val="solid"/>
+                      <a:round/>
+                      <a:headEnd type="none" w="med" len="med"/>
+                      <a:tailEnd type="none" w="med" len="med"/>
+                    </a:lnB>
+                    <a:solidFill>
+                      <a:srgbClr val="F8FAFC"/>
+                    </a:solidFill>
+                  </a:tcPr>
+                </a:tc>
+              </a:tr>
+              <a:tr h="457200">
+                <a:tc>
+                  <a:txBody>
+                    <a:bodyPr/>
+                    <a:lstStyle/>
+                    <a:p>
+                      <a:pPr algn="l" indent="0" marL="0">
+                        <a:buNone/>
+                      </a:pPr>
+                      <a:r>
+                        <a:rPr lang="en-US" sz="900" dirty="0">
+                          <a:solidFill>
+                            <a:srgbClr val="334155"/>
+                          </a:solidFill>
+                        </a:rPr>
+                        <a:t>第3週 高賣</a:t>
+                      </a:r>
+                      <a:endParaRPr lang="en-US" sz="900" dirty="0"/>
+                    </a:p>
+                  </a:txBody>
+                  <a:tcPr marL="73152" marR="73152" marT="45720" marB="45720" anchor="ctr">
+                    <a:lnL w="9525" cap="flat" cmpd="sng" algn="ctr">
+                      <a:solidFill>
+                        <a:srgbClr val="E2E8F0"/>
+                      </a:solidFill>
+                      <a:prstDash val="solid"/>
+                      <a:round/>
+                      <a:headEnd type="none" w="med" len="med"/>
+                      <a:tailEnd type="none" w="med" len="med"/>
+                    </a:lnL>
+                    <a:lnR w="9525" cap="flat" cmpd="sng" algn="ctr">
+                      <a:solidFill>
+                        <a:srgbClr val="E2E8F0"/>
+                      </a:solidFill>
+                      <a:prstDash val="solid"/>
+                      <a:round/>
+                      <a:headEnd type="none" w="med" len="med"/>
+                      <a:tailEnd type="none" w="med" len="med"/>
+                    </a:lnR>
+                    <a:lnT w="9525" cap="flat" cmpd="sng" algn="ctr">
+                      <a:solidFill>
+                        <a:srgbClr val="E2E8F0"/>
+                      </a:solidFill>
+                      <a:prstDash val="solid"/>
+                      <a:round/>
+                      <a:headEnd type="none" w="med" len="med"/>
+                      <a:tailEnd type="none" w="med" len="med"/>
+                    </a:lnT>
+                    <a:lnB w="9525" cap="flat" cmpd="sng" algn="ctr">
+                      <a:solidFill>
+                        <a:srgbClr val="E2E8F0"/>
+                      </a:solidFill>
+                      <a:prstDash val="solid"/>
+                      <a:round/>
+                      <a:headEnd type="none" w="med" len="med"/>
+                      <a:tailEnd type="none" w="med" len="med"/>
+                    </a:lnB>
+                    <a:solidFill>
+                      <a:srgbClr val="FFFFFF"/>
+                    </a:solidFill>
+                  </a:tcPr>
+                </a:tc>
+                <a:tc>
+                  <a:txBody>
+                    <a:bodyPr/>
+                    <a:lstStyle/>
+                    <a:p>
+                      <a:pPr algn="l" indent="0" marL="0">
+                        <a:buNone/>
+                      </a:pPr>
+                      <a:r>
+                        <a:rPr lang="en-US" sz="900" dirty="0">
+                          <a:solidFill>
+                            <a:srgbClr val="334155"/>
+                          </a:solidFill>
+                        </a:rPr>
+                        <a:t>同一行使價 $55,900 滾動掛單</a:t>
+                      </a:r>
+                      <a:endParaRPr lang="en-US" sz="900" dirty="0"/>
+                    </a:p>
+                  </a:txBody>
+                  <a:tcPr marL="73152" marR="73152" marT="45720" marB="45720" anchor="ctr">
+                    <a:lnL w="9525" cap="flat" cmpd="sng" algn="ctr">
+                      <a:solidFill>
+                        <a:srgbClr val="E2E8F0"/>
+                      </a:solidFill>
+                      <a:prstDash val="solid"/>
+                      <a:round/>
+                      <a:headEnd type="none" w="med" len="med"/>
+                      <a:tailEnd type="none" w="med" len="med"/>
+                    </a:lnL>
+                    <a:lnR w="9525" cap="flat" cmpd="sng" algn="ctr">
+                      <a:solidFill>
+                        <a:srgbClr val="E2E8F0"/>
+                      </a:solidFill>
+                      <a:prstDash val="solid"/>
+                      <a:round/>
+                      <a:headEnd type="none" w="med" len="med"/>
+                      <a:tailEnd type="none" w="med" len="med"/>
+                    </a:lnR>
+                    <a:lnT w="9525" cap="flat" cmpd="sng" algn="ctr">
+                      <a:solidFill>
+                        <a:srgbClr val="E2E8F0"/>
+                      </a:solidFill>
+                      <a:prstDash val="solid"/>
+                      <a:round/>
+                      <a:headEnd type="none" w="med" len="med"/>
+                      <a:tailEnd type="none" w="med" len="med"/>
+                    </a:lnT>
+                    <a:lnB w="9525" cap="flat" cmpd="sng" algn="ctr">
+                      <a:solidFill>
+                        <a:srgbClr val="E2E8F0"/>
+                      </a:solidFill>
+                      <a:prstDash val="solid"/>
+                      <a:round/>
+                      <a:headEnd type="none" w="med" len="med"/>
+                      <a:tailEnd type="none" w="med" len="med"/>
+                    </a:lnB>
+                    <a:solidFill>
+                      <a:srgbClr val="FFFFFF"/>
+                    </a:solidFill>
+                  </a:tcPr>
+                </a:tc>
+                <a:tc>
+                  <a:txBody>
+                    <a:bodyPr/>
+                    <a:lstStyle/>
+                    <a:p>
+                      <a:pPr algn="l" indent="0" marL="0">
+                        <a:buNone/>
+                      </a:pPr>
+                      <a:r>
+                        <a:rPr lang="en-US" sz="900" dirty="0">
+                          <a:solidFill>
+                            <a:srgbClr val="334155"/>
+                          </a:solidFill>
+                        </a:rPr>
+                        <a:t>38%</a:t>
+                      </a:r>
+                      <a:endParaRPr lang="en-US" sz="900" dirty="0"/>
+                    </a:p>
+                  </a:txBody>
+                  <a:tcPr marL="73152" marR="73152" marT="45720" marB="45720" anchor="ctr">
+                    <a:lnL w="9525" cap="flat" cmpd="sng" algn="ctr">
+                      <a:solidFill>
+                        <a:srgbClr val="E2E8F0"/>
+                      </a:solidFill>
+                      <a:prstDash val="solid"/>
+                      <a:round/>
+                      <a:headEnd type="none" w="med" len="med"/>
+                      <a:tailEnd type="none" w="med" len="med"/>
+                    </a:lnL>
+                    <a:lnR w="9525" cap="flat" cmpd="sng" algn="ctr">
+                      <a:solidFill>
+                        <a:srgbClr val="E2E8F0"/>
+                      </a:solidFill>
+                      <a:prstDash val="solid"/>
+                      <a:round/>
+                      <a:headEnd type="none" w="med" len="med"/>
+                      <a:tailEnd type="none" w="med" len="med"/>
+                    </a:lnR>
+                    <a:lnT w="9525" cap="flat" cmpd="sng" algn="ctr">
+                      <a:solidFill>
+                        <a:srgbClr val="E2E8F0"/>
+                      </a:solidFill>
+                      <a:prstDash val="solid"/>
+                      <a:round/>
+                      <a:headEnd type="none" w="med" len="med"/>
+                      <a:tailEnd type="none" w="med" len="med"/>
+                    </a:lnT>
+                    <a:lnB w="9525" cap="flat" cmpd="sng" algn="ctr">
+                      <a:solidFill>
+                        <a:srgbClr val="E2E8F0"/>
+                      </a:solidFill>
+                      <a:prstDash val="solid"/>
+                      <a:round/>
+                      <a:headEnd type="none" w="med" len="med"/>
+                      <a:tailEnd type="none" w="med" len="med"/>
+                    </a:lnB>
+                    <a:solidFill>
+                      <a:srgbClr val="FFFFFF"/>
+                    </a:solidFill>
+                  </a:tcPr>
+                </a:tc>
+                <a:tc>
+                  <a:txBody>
+                    <a:bodyPr/>
+                    <a:lstStyle/>
+                    <a:p>
+                      <a:pPr algn="l" indent="0" marL="0">
+                        <a:buNone/>
+                      </a:pPr>
+                      <a:r>
+                        <a:rPr lang="en-US" sz="900" dirty="0">
+                          <a:solidFill>
+                            <a:srgbClr val="334155"/>
+                          </a:solidFill>
+                        </a:rPr>
+                        <a:t>$7,042</a:t>
+                      </a:r>
+                      <a:endParaRPr lang="en-US" sz="900" dirty="0"/>
+                    </a:p>
+                  </a:txBody>
+                  <a:tcPr marL="73152" marR="73152" marT="45720" marB="45720" anchor="ctr">
+                    <a:lnL w="9525" cap="flat" cmpd="sng" algn="ctr">
+                      <a:solidFill>
+                        <a:srgbClr val="E2E8F0"/>
+                      </a:solidFill>
+                      <a:prstDash val="solid"/>
+                      <a:round/>
+                      <a:headEnd type="none" w="med" len="med"/>
+                      <a:tailEnd type="none" w="med" len="med"/>
+                    </a:lnL>
+                    <a:lnR w="9525" cap="flat" cmpd="sng" algn="ctr">
+                      <a:solidFill>
+                        <a:srgbClr val="E2E8F0"/>
+                      </a:solidFill>
+                      <a:prstDash val="solid"/>
+                      <a:round/>
+                      <a:headEnd type="none" w="med" len="med"/>
+                      <a:tailEnd type="none" w="med" len="med"/>
+                    </a:lnR>
+                    <a:lnT w="9525" cap="flat" cmpd="sng" algn="ctr">
+                      <a:solidFill>
+                        <a:srgbClr val="E2E8F0"/>
+                      </a:solidFill>
+                      <a:prstDash val="solid"/>
+                      <a:round/>
+                      <a:headEnd type="none" w="med" len="med"/>
+                      <a:tailEnd type="none" w="med" len="med"/>
+                    </a:lnT>
+                    <a:lnB w="9525" cap="flat" cmpd="sng" algn="ctr">
+                      <a:solidFill>
+                        <a:srgbClr val="E2E8F0"/>
+                      </a:solidFill>
+                      <a:prstDash val="solid"/>
+                      <a:round/>
+                      <a:headEnd type="none" w="med" len="med"/>
+                      <a:tailEnd type="none" w="med" len="med"/>
+                    </a:lnB>
+                    <a:solidFill>
+                      <a:srgbClr val="FFFFFF"/>
+                    </a:solidFill>
+                  </a:tcPr>
+                </a:tc>
+                <a:tc>
+                  <a:txBody>
+                    <a:bodyPr/>
+                    <a:lstStyle/>
+                    <a:p>
+                      <a:pPr algn="l" indent="0" marL="0">
+                        <a:buNone/>
+                      </a:pPr>
+                      <a:r>
+                        <a:rPr lang="en-US" sz="900" dirty="0">
+                          <a:solidFill>
+                            <a:srgbClr val="334155"/>
+                          </a:solidFill>
+                        </a:rPr>
+                        <a:t>漲破，換回USDT</a:t>
+                      </a:r>
+                      <a:endParaRPr lang="en-US" sz="900" dirty="0"/>
+                    </a:p>
+                  </a:txBody>
+                  <a:tcPr marL="73152" marR="73152" marT="45720" marB="45720" anchor="ctr">
+                    <a:lnL w="9525" cap="flat" cmpd="sng" algn="ctr">
+                      <a:solidFill>
+                        <a:srgbClr val="E2E8F0"/>
+                      </a:solidFill>
+                      <a:prstDash val="solid"/>
+                      <a:round/>
+                      <a:headEnd type="none" w="med" len="med"/>
+                      <a:tailEnd type="none" w="med" len="med"/>
+                    </a:lnL>
+                    <a:lnR w="9525" cap="flat" cmpd="sng" algn="ctr">
+                      <a:solidFill>
+                        <a:srgbClr val="E2E8F0"/>
+                      </a:solidFill>
+                      <a:prstDash val="solid"/>
+                      <a:round/>
+                      <a:headEnd type="none" w="med" len="med"/>
+                      <a:tailEnd type="none" w="med" len="med"/>
+                    </a:lnR>
+                    <a:lnT w="9525" cap="flat" cmpd="sng" algn="ctr">
+                      <a:solidFill>
+                        <a:srgbClr val="E2E8F0"/>
+                      </a:solidFill>
+                      <a:prstDash val="solid"/>
+                      <a:round/>
+                      <a:headEnd type="none" w="med" len="med"/>
+                      <a:tailEnd type="none" w="med" len="med"/>
+                    </a:lnT>
+                    <a:lnB w="9525" cap="flat" cmpd="sng" algn="ctr">
+                      <a:solidFill>
+                        <a:srgbClr val="E2E8F0"/>
+                      </a:solidFill>
+                      <a:prstDash val="solid"/>
+                      <a:round/>
+                      <a:headEnd type="none" w="med" len="med"/>
+                      <a:tailEnd type="none" w="med" len="med"/>
+                    </a:lnB>
+                    <a:solidFill>
+                      <a:srgbClr val="FFFFFF"/>
+                    </a:solidFill>
+                  </a:tcPr>
+                </a:tc>
+              </a:tr>
+            </a:tbl>
+          </a:graphicData>
+        </a:graphic>
+      </p:graphicFrame>
+      <p:sp>
+        <p:nvSpPr>
+          <p:cNvPr id="8" name="Shape 5"/>
+          <p:cNvSpPr/>
+          <p:nvPr/>
+        </p:nvSpPr>
+        <p:spPr>
+          <a:xfrm>
+            <a:off x="548640" y="3611880"/>
+            <a:ext cx="3566160" cy="1417320"/>
+          </a:xfrm>
+          <a:prstGeom prst="roundRect">
+            <a:avLst>
+              <a:gd name="adj" fmla="val 5161"/>
+            </a:avLst>
+          </a:prstGeom>
+          <a:solidFill>
+            <a:srgbClr val="EFF6FF"/>
+          </a:solidFill>
+          <a:ln/>
+        </p:spPr>
+      </p:sp>
+      <p:sp>
+        <p:nvSpPr>
+          <p:cNvPr id="9" name="Text 6"/>
+          <p:cNvSpPr txBox="1"/>
+          <p:nvPr/>
+        </p:nvSpPr>
+        <p:spPr>
+          <a:xfrm>
+            <a:off x="685800" y="3721608"/>
+            <a:ext cx="3291840" cy="914400"/>
+          </a:xfrm>
+          <a:prstGeom prst="rect">
+            <a:avLst/>
+          </a:prstGeom>
+          <a:noFill/>
+          <a:ln/>
+        </p:spPr>
+        <p:txBody>
+          <a:bodyPr wrap="square" lIns="0" tIns="0" rIns="0" bIns="0" rtlCol="0" anchor="b"/>
+          <a:lstStyle/>
+          <a:p>
+            <a:pPr algn="ctr" indent="0" marL="0">
+              <a:buNone/>
+            </a:pPr>
+            <a:r>
+              <a:rPr lang="en-US" sz="2200" b="1" dirty="0">
+                <a:solidFill>
+                  <a:srgbClr val="16A34A"/>
+                </a:solidFill>
+                <a:latin typeface="Microsoft JhengHei" pitchFamily="34" charset="0"/>
+                <a:ea typeface="Microsoft JhengHei" pitchFamily="34" charset="-122"/>
+                <a:cs typeface="Microsoft JhengHei" pitchFamily="34" charset="-120"/>
+              </a:rPr>
+              <a:t>+2.05%（3週）</a:t>
+            </a:r>
+            <a:endParaRPr lang="en-US" sz="2200" dirty="0"/>
+          </a:p>
+        </p:txBody>
+      </p:sp>
+      <p:sp>
+        <p:nvSpPr>
+          <p:cNvPr id="10" name="Text 7"/>
+          <p:cNvSpPr txBox="1"/>
+          <p:nvPr/>
+        </p:nvSpPr>
+        <p:spPr>
+          <a:xfrm>
+            <a:off x="640080" y="4645152"/>
+            <a:ext cx="3383280" cy="320040"/>
+          </a:xfrm>
+          <a:prstGeom prst="rect">
+            <a:avLst/>
+          </a:prstGeom>
+          <a:noFill/>
+          <a:ln/>
+        </p:spPr>
+        <p:txBody>
+          <a:bodyPr wrap="square" lIns="0" tIns="0" rIns="0" bIns="0" rtlCol="0" anchor="t"/>
+          <a:lstStyle/>
+          <a:p>
+            <a:pPr algn="ctr" indent="0" marL="0">
+              <a:buNone/>
+            </a:pPr>
+            <a:r>
+              <a:rPr lang="en-US" sz="1050" dirty="0">
+                <a:solidFill>
+                  <a:srgbClr val="334155"/>
+                </a:solidFill>
+                <a:latin typeface="Microsoft JhengHei" pitchFamily="34" charset="0"/>
+                <a:ea typeface="Microsoft JhengHei" pitchFamily="34" charset="-122"/>
+                <a:cs typeface="Microsoft JhengHei" pitchFamily="34" charset="-120"/>
+              </a:rPr>
+              <a:t>順利路徑：本金全數取回＋累積權利金 $20,535</a:t>
+            </a:r>
+            <a:endParaRPr lang="en-US" sz="1050" dirty="0"/>
+          </a:p>
+        </p:txBody>
+      </p:sp>
+      <p:sp>
+        <p:nvSpPr>
+          <p:cNvPr id="11" name="Shape 8"/>
+          <p:cNvSpPr/>
+          <p:nvPr/>
+        </p:nvSpPr>
+        <p:spPr>
+          <a:xfrm>
+            <a:off x="4297680" y="3611880"/>
+            <a:ext cx="3566160" cy="1417320"/>
+          </a:xfrm>
+          <a:prstGeom prst="roundRect">
+            <a:avLst>
+              <a:gd name="adj" fmla="val 5161"/>
+            </a:avLst>
+          </a:prstGeom>
+          <a:solidFill>
+            <a:srgbClr val="F8FAFC"/>
+          </a:solidFill>
+          <a:ln/>
+        </p:spPr>
+      </p:sp>
+      <p:sp>
+        <p:nvSpPr>
+          <p:cNvPr id="12" name="Text 9"/>
+          <p:cNvSpPr txBox="1"/>
+          <p:nvPr/>
+        </p:nvSpPr>
+        <p:spPr>
+          <a:xfrm>
+            <a:off x="4434840" y="3721608"/>
+            <a:ext cx="3291840" cy="914400"/>
+          </a:xfrm>
+          <a:prstGeom prst="rect">
+            <a:avLst/>
+          </a:prstGeom>
+          <a:noFill/>
+          <a:ln/>
+        </p:spPr>
+        <p:txBody>
+          <a:bodyPr wrap="square" lIns="0" tIns="0" rIns="0" bIns="0" rtlCol="0" anchor="b"/>
+          <a:lstStyle/>
+          <a:p>
+            <a:pPr algn="ctr" indent="0" marL="0">
+              <a:buNone/>
+            </a:pPr>
+            <a:r>
+              <a:rPr lang="en-US" sz="2200" b="1" dirty="0">
+                <a:solidFill>
+                  <a:srgbClr val="B45309"/>
+                </a:solidFill>
+                <a:latin typeface="Microsoft JhengHei" pitchFamily="34" charset="0"/>
+                <a:ea typeface="Microsoft JhengHei" pitchFamily="34" charset="-122"/>
+                <a:cs typeface="Microsoft JhengHei" pitchFamily="34" charset="-120"/>
+              </a:rPr>
+              <a:t>-28.4%（未實現）</a:t>
+            </a:r>
+            <a:endParaRPr lang="en-US" sz="2200" dirty="0"/>
+          </a:p>
+        </p:txBody>
+      </p:sp>
+      <p:sp>
+        <p:nvSpPr>
+          <p:cNvPr id="13" name="Text 10"/>
+          <p:cNvSpPr txBox="1"/>
+          <p:nvPr/>
+        </p:nvSpPr>
+        <p:spPr>
+          <a:xfrm>
+            <a:off x="4389120" y="4645152"/>
+            <a:ext cx="3383280" cy="320040"/>
+          </a:xfrm>
+          <a:prstGeom prst="rect">
+            <a:avLst/>
+          </a:prstGeom>
+          <a:noFill/>
+          <a:ln/>
+        </p:spPr>
+        <p:txBody>
+          <a:bodyPr wrap="square" lIns="0" tIns="0" rIns="0" bIns="0" rtlCol="0" anchor="t"/>
+          <a:lstStyle/>
+          <a:p>
+            <a:pPr algn="ctr" indent="0" marL="0">
+              <a:buNone/>
+            </a:pPr>
+            <a:r>
+              <a:rPr lang="en-US" sz="1050" dirty="0">
+                <a:solidFill>
+                  <a:srgbClr val="334155"/>
+                </a:solidFill>
+                <a:latin typeface="Microsoft JhengHei" pitchFamily="34" charset="0"/>
+                <a:ea typeface="Microsoft JhengHei" pitchFamily="34" charset="-122"/>
+                <a:cs typeface="Microsoft JhengHei" pitchFamily="34" charset="-120"/>
+              </a:rPr>
+              <a:t>對照情境：10週價格未回升，帳面浮虧 $284,436</a:t>
+            </a:r>
+            <a:endParaRPr lang="en-US" sz="1050" dirty="0"/>
+          </a:p>
+        </p:txBody>
+      </p:sp>
+      <p:sp>
+        <p:nvSpPr>
+          <p:cNvPr id="14" name="Shape 11"/>
+          <p:cNvSpPr/>
+          <p:nvPr/>
+        </p:nvSpPr>
+        <p:spPr>
+          <a:xfrm>
+            <a:off x="8001000" y="3611880"/>
+            <a:ext cx="3639312" cy="1417320"/>
+          </a:xfrm>
+          <a:prstGeom prst="roundRect">
+            <a:avLst>
+              <a:gd name="adj" fmla="val 5161"/>
+            </a:avLst>
+          </a:prstGeom>
+          <a:solidFill>
+            <a:srgbClr val="F8FAFC"/>
+          </a:solidFill>
+          <a:ln w="9525">
+            <a:solidFill>
+              <a:srgbClr val="E2E8F0"/>
+            </a:solidFill>
+            <a:prstDash val="solid"/>
+          </a:ln>
+          <a:effectLst>
+            <a:outerShdw sx="100000" sy="100000" kx="0" ky="0" algn="bl" rotWithShape="0" blurRad="76200" dist="25400" dir="5400000">
+              <a:srgbClr val="1E293B">
+                <a:alpha val="8000"/>
+              </a:srgbClr>
+            </a:outerShdw>
+          </a:effectLst>
+        </p:spPr>
+      </p:sp>
+      <p:sp>
+        <p:nvSpPr>
+          <p:cNvPr id="15" name="Text 12"/>
+          <p:cNvSpPr txBox="1"/>
+          <p:nvPr/>
+        </p:nvSpPr>
+        <p:spPr>
+          <a:xfrm>
+            <a:off x="8202168" y="3758184"/>
+            <a:ext cx="3236976" cy="320040"/>
+          </a:xfrm>
+          <a:prstGeom prst="rect">
+            <a:avLst/>
+          </a:prstGeom>
+          <a:noFill/>
+          <a:ln/>
+        </p:spPr>
+        <p:txBody>
+          <a:bodyPr wrap="square" lIns="0" tIns="0" rIns="0" bIns="0" rtlCol="0" anchor="ctr"/>
+          <a:lstStyle/>
+          <a:p>
+            <a:pPr algn="l" indent="0" marL="0">
+              <a:buNone/>
+            </a:pPr>
+            <a:r>
+              <a:rPr lang="en-US" sz="1300" b="1" dirty="0">
+                <a:solidFill>
+                  <a:srgbClr val="0F172A"/>
+                </a:solidFill>
+                <a:latin typeface="Microsoft JhengHei" pitchFamily="34" charset="0"/>
+                <a:ea typeface="Microsoft JhengHei" pitchFamily="34" charset="-122"/>
+                <a:cs typeface="Microsoft JhengHei" pitchFamily="34" charset="-120"/>
+              </a:rPr>
+              <a:t>關鍵前提</a:t>
+            </a:r>
+            <a:endParaRPr lang="en-US" sz="1300" dirty="0"/>
+          </a:p>
+        </p:txBody>
+      </p:sp>
+      <p:sp>
+        <p:nvSpPr>
+          <p:cNvPr id="16" name="Text 13"/>
+          <p:cNvSpPr txBox="1"/>
+          <p:nvPr/>
+        </p:nvSpPr>
+        <p:spPr>
+          <a:xfrm>
+            <a:off x="8202168" y="4114800"/>
+            <a:ext cx="3236976" cy="758952"/>
+          </a:xfrm>
+          <a:prstGeom prst="rect">
+            <a:avLst/>
+          </a:prstGeom>
+          <a:noFill/>
+          <a:ln/>
+        </p:spPr>
+        <p:txBody>
+          <a:bodyPr wrap="square" lIns="0" tIns="0" rIns="0" bIns="0" rtlCol="0" anchor="t"/>
+          <a:lstStyle/>
+          <a:p>
+            <a:pPr algn="l" indent="0" marL="0">
+              <a:lnSpc>
+                <a:spcPct val="115000"/>
+              </a:lnSpc>
+              <a:buNone/>
+            </a:pPr>
+            <a:r>
+              <a:rPr lang="en-US" sz="1050" dirty="0">
+                <a:solidFill>
+                  <a:srgbClr val="334155"/>
+                </a:solidFill>
+                <a:latin typeface="Microsoft JhengHei" pitchFamily="34" charset="0"/>
+                <a:ea typeface="Microsoft JhengHei" pitchFamily="34" charset="-122"/>
+                <a:cs typeface="Microsoft JhengHei" pitchFamily="34" charset="-120"/>
+              </a:rPr>
+              <a:t>「不會虧錢」僅在最終價格確實回升至原行使價、且過程中未改用更低行使價時成立。</a:t>
+            </a:r>
+            <a:endParaRPr lang="en-US" sz="1050" dirty="0"/>
+          </a:p>
+        </p:txBody>
+      </p:sp>
+      <p:sp>
+        <p:nvSpPr>
+          <p:cNvPr id="17" name="Shape 14"/>
+          <p:cNvSpPr/>
+          <p:nvPr/>
+        </p:nvSpPr>
+        <p:spPr>
+          <a:xfrm>
+            <a:off x="548640" y="5212080"/>
+            <a:ext cx="11094415" cy="1097280"/>
+          </a:xfrm>
+          <a:prstGeom prst="roundRect">
+            <a:avLst>
+              <a:gd name="adj" fmla="val 6667"/>
+            </a:avLst>
+          </a:prstGeom>
+          <a:solidFill>
+            <a:srgbClr val="EFF6FF"/>
+          </a:solidFill>
+          <a:ln w="9525">
+            <a:solidFill>
+              <a:srgbClr val="E2E8F0"/>
+            </a:solidFill>
+            <a:prstDash val="solid"/>
+          </a:ln>
+          <a:effectLst>
+            <a:outerShdw sx="100000" sy="100000" kx="0" ky="0" algn="bl" rotWithShape="0" blurRad="76200" dist="25400" dir="5400000">
+              <a:srgbClr val="1E293B">
+                <a:alpha val="8000"/>
+              </a:srgbClr>
+            </a:outerShdw>
+          </a:effectLst>
+        </p:spPr>
+      </p:sp>
+      <p:sp>
+        <p:nvSpPr>
+          <p:cNvPr id="18" name="Text 15"/>
+          <p:cNvSpPr txBox="1"/>
+          <p:nvPr/>
+        </p:nvSpPr>
+        <p:spPr>
+          <a:xfrm>
+            <a:off x="749808" y="5358384"/>
+            <a:ext cx="10692079" cy="320040"/>
+          </a:xfrm>
+          <a:prstGeom prst="rect">
+            <a:avLst/>
+          </a:prstGeom>
+          <a:noFill/>
+          <a:ln/>
+        </p:spPr>
+        <p:txBody>
+          <a:bodyPr wrap="square" lIns="0" tIns="0" rIns="0" bIns="0" rtlCol="0" anchor="ctr"/>
+          <a:lstStyle/>
+          <a:p>
+            <a:pPr algn="l" indent="0" marL="0">
+              <a:buNone/>
+            </a:pPr>
+            <a:r>
+              <a:rPr lang="en-US" sz="1300" b="1" dirty="0">
+                <a:solidFill>
+                  <a:srgbClr val="0F172A"/>
+                </a:solidFill>
+                <a:latin typeface="Microsoft JhengHei" pitchFamily="34" charset="0"/>
+                <a:ea typeface="Microsoft JhengHei" pitchFamily="34" charset="-122"/>
+                <a:cs typeface="Microsoft JhengHei" pitchFamily="34" charset="-120"/>
+              </a:rPr>
+              <a:t>財務部應理解之三項限制</a:t>
+            </a:r>
+            <a:endParaRPr lang="en-US" sz="1300" dirty="0"/>
+          </a:p>
+        </p:txBody>
+      </p:sp>
+      <p:sp>
+        <p:nvSpPr>
+          <p:cNvPr id="19" name="Text 16"/>
+          <p:cNvSpPr txBox="1"/>
+          <p:nvPr/>
+        </p:nvSpPr>
+        <p:spPr>
+          <a:xfrm>
+            <a:off x="749808" y="5715000"/>
+            <a:ext cx="10692079" cy="438912"/>
+          </a:xfrm>
+          <a:prstGeom prst="rect">
+            <a:avLst/>
+          </a:prstGeom>
+          <a:noFill/>
+          <a:ln/>
+        </p:spPr>
+        <p:txBody>
+          <a:bodyPr wrap="square" lIns="0" tIns="0" rIns="0" bIns="0" rtlCol="0" anchor="t"/>
+          <a:lstStyle/>
+          <a:p>
+            <a:pPr algn="l" indent="0" marL="0">
+              <a:lnSpc>
+                <a:spcPct val="115000"/>
+              </a:lnSpc>
+              <a:buNone/>
+            </a:pPr>
+            <a:r>
+              <a:rPr lang="en-US" sz="1050" dirty="0">
+                <a:solidFill>
+                  <a:srgbClr val="334155"/>
+                </a:solidFill>
+                <a:latin typeface="Microsoft JhengHei" pitchFamily="34" charset="0"/>
+                <a:ea typeface="Microsoft JhengHei" pitchFamily="34" charset="-122"/>
+                <a:cs typeface="Microsoft JhengHei" pitchFamily="34" charset="-120"/>
+              </a:rPr>
+              <a:t>① 權利金隨套牢加深而遞減（越價外，權利金越低，非維持初始水準）｜② 價格回升時間無保證，資金於等待期間無法投入其他生息工具（機會成本）｜③ FVTPL會計原則下，未回升期間之BTC部位仍須逐期認列未實現跌價損失，非「零風險」</a:t>
+            </a:r>
+            <a:endParaRPr lang="en-US" sz="1050" dirty="0"/>
+          </a:p>
+        </p:txBody>
+      </p:sp>
+      <p:sp>
+        <p:nvSpPr>
+          <p:cNvPr id="20" name="Text 17"/>
+          <p:cNvSpPr txBox="1"/>
+          <p:nvPr/>
+        </p:nvSpPr>
+        <p:spPr>
+          <a:xfrm>
+            <a:off x="457200" y="6492240"/>
+            <a:ext cx="5486400" cy="274320"/>
+          </a:xfrm>
+          <a:prstGeom prst="rect">
+            <a:avLst/>
+          </a:prstGeom>
+          <a:noFill/>
+          <a:ln/>
+        </p:spPr>
+        <p:txBody>
+          <a:bodyPr wrap="square" lIns="0" tIns="0" rIns="0" bIns="0" rtlCol="0" anchor="ctr"/>
+          <a:lstStyle/>
+          <a:p>
+            <a:pPr algn="l" indent="0" marL="0">
+              <a:buNone/>
+            </a:pPr>
+            <a:r>
+              <a:rPr lang="en-US" sz="900" dirty="0">
+                <a:solidFill>
+                  <a:srgbClr val="64748B"/>
+                </a:solidFill>
+                <a:latin typeface="Microsoft JhengHei" pitchFamily="34" charset="0"/>
+                <a:ea typeface="Microsoft JhengHei" pitchFamily="34" charset="-122"/>
+                <a:cs typeface="Microsoft JhengHei" pitchFamily="34" charset="-120"/>
+              </a:rPr>
+              <a:t>TSGEX 資產管理部｜內部機密</a:t>
+            </a:r>
+            <a:endParaRPr lang="en-US" sz="900" dirty="0"/>
+          </a:p>
+        </p:txBody>
+      </p:sp>
+      <p:sp>
+        <p:nvSpPr>
+          <p:cNvPr id="21" name="Text 18"/>
+          <p:cNvSpPr txBox="1"/>
+          <p:nvPr/>
+        </p:nvSpPr>
+        <p:spPr>
+          <a:xfrm>
+            <a:off x="9905695" y="6492240"/>
+            <a:ext cx="1828800" cy="274320"/>
+          </a:xfrm>
+          <a:prstGeom prst="rect">
+            <a:avLst/>
+          </a:prstGeom>
+          <a:noFill/>
+          <a:ln/>
+        </p:spPr>
+        <p:txBody>
+          <a:bodyPr wrap="square" lIns="0" tIns="0" rIns="0" bIns="0" rtlCol="0" anchor="ctr"/>
+          <a:lstStyle/>
+          <a:p>
+            <a:pPr algn="r" indent="0" marL="0">
+              <a:buNone/>
+            </a:pPr>
+            <a:r>
+              <a:rPr lang="en-US" sz="900" dirty="0">
+                <a:solidFill>
+                  <a:srgbClr val="64748B"/>
+                </a:solidFill>
+                <a:latin typeface="Microsoft JhengHei" pitchFamily="34" charset="0"/>
+                <a:ea typeface="Microsoft JhengHei" pitchFamily="34" charset="-122"/>
+                <a:cs typeface="Microsoft JhengHei" pitchFamily="34" charset="-120"/>
+              </a:rPr>
+              <a:t>10 / 15</a:t>
+            </a:r>
+            <a:endParaRPr lang="en-US" sz="900" dirty="0"/>
+          </a:p>
+        </p:txBody>
+      </p:sp>
+    </p:spTree>
+  </p:cSld>
+  <p:clrMapOvr>
+    <a:masterClrMapping/>
+  </p:clrMapOvr>
+</p:sld>
+</file>
+
+<file path=ppt/slides/slide11.xml><?xml version="1.0" encoding="utf-8"?>
+<p:sld xmlns:a="http://schemas.openxmlformats.org/drawingml/2006/main" xmlns:r="http://schemas.openxmlformats.org/officeDocument/2006/relationships" xmlns:p="http://schemas.openxmlformats.org/presentationml/2006/main">
+  <p:cSld name="Slide 11">
+    <p:bg>
+      <p:bgPr>
+        <a:solidFill>
+          <a:srgbClr val="FFFFFF"/>
+        </a:solidFill>
+      </p:bgPr>
+    </p:bg>
+    <p:spTree>
+      <p:nvGrpSpPr>
+        <p:cNvPr id="1" name=""/>
+        <p:cNvGrpSpPr/>
+        <p:nvPr/>
+      </p:nvGrpSpPr>
+      <p:grpSpPr>
+        <a:xfrm>
+          <a:off x="0" y="0"/>
+          <a:ext cx="0" cy="0"/>
+          <a:chOff x="0" y="0"/>
+          <a:chExt cx="0" cy="0"/>
+        </a:xfrm>
+      </p:grpSpPr>
+      <p:sp>
+        <p:nvSpPr>
+          <p:cNvPr id="2" name="Text 0"/>
+          <p:cNvSpPr txBox="1"/>
+          <p:nvPr/>
+        </p:nvSpPr>
+        <p:spPr>
+          <a:xfrm>
+            <a:off x="548640" y="365760"/>
+            <a:ext cx="11094415" cy="640080"/>
+          </a:xfrm>
+          <a:prstGeom prst="rect">
+            <a:avLst/>
+          </a:prstGeom>
+          <a:noFill/>
+          <a:ln/>
+        </p:spPr>
+        <p:txBody>
+          <a:bodyPr wrap="square" lIns="0" tIns="0" rIns="0" bIns="0" rtlCol="0" anchor="ctr"/>
+          <a:lstStyle/>
+          <a:p>
+            <a:pPr algn="l" indent="0" marL="0">
+              <a:buNone/>
+            </a:pPr>
+            <a:r>
+              <a:rPr lang="en-US" sz="2800" b="1" dirty="0">
+                <a:solidFill>
+                  <a:srgbClr val="0F172A"/>
+                </a:solidFill>
+                <a:latin typeface="Microsoft JhengHei" pitchFamily="34" charset="0"/>
+                <a:ea typeface="Microsoft JhengHei" pitchFamily="34" charset="-122"/>
+                <a:cs typeface="Microsoft JhengHei" pitchFamily="34" charset="-120"/>
+              </a:rPr>
               <a:t>⑤ Binance 雙幣投資（Dual Investment）</a:t>
             </a:r>
             <a:endParaRPr lang="en-US" sz="2800" dirty="0"/>
@@ -3643,7 +5726,7 @@
       </p:sp>
       <p:graphicFrame>
         <p:nvGraphicFramePr>
-          <p:cNvPr id="11" name="Table 0"/>
+          <p:cNvPr id="12" name="Table 0"/>
           <p:cNvGraphicFramePr>
             <a:graphicFrameLocks noGrp="1"/>
           </p:cNvGraphicFramePr>
@@ -4999,7 +7082,7 @@
                 <a:ea typeface="Microsoft JhengHei" pitchFamily="34" charset="-122"/>
                 <a:cs typeface="Microsoft JhengHei" pitchFamily="34" charset="-120"/>
               </a:rPr>
-              <a:t>10 / 14</a:t>
+              <a:t>11 / 15</a:t>
             </a:r>
             <a:endParaRPr lang="en-US" sz="900" dirty="0"/>
           </a:p>
@@ -5013,9 +7096,9 @@
 </p:sld>
 </file>
 
-<file path=ppt/slides/slide11.xml><?xml version="1.0" encoding="utf-8"?>
+<file path=ppt/slides/slide12.xml><?xml version="1.0" encoding="utf-8"?>
 <p:sld xmlns:a="http://schemas.openxmlformats.org/drawingml/2006/main" xmlns:r="http://schemas.openxmlformats.org/officeDocument/2006/relationships" xmlns:p="http://schemas.openxmlformats.org/presentationml/2006/main">
-  <p:cSld name="Slide 11">
+  <p:cSld name="Slide 12">
     <p:bg>
       <p:bgPr>
         <a:solidFill>
@@ -5117,7 +7200,7 @@
       </p:sp>
       <p:graphicFrame>
         <p:nvGraphicFramePr>
-          <p:cNvPr id="12" name="Table 0"/>
+          <p:cNvPr id="13" name="Table 0"/>
           <p:cNvGraphicFramePr>
             <a:graphicFrameLocks noGrp="1"/>
           </p:cNvGraphicFramePr>
@@ -6941,7 +9024,7 @@
                 <a:ea typeface="Microsoft JhengHei" pitchFamily="34" charset="-122"/>
                 <a:cs typeface="Microsoft JhengHei" pitchFamily="34" charset="-120"/>
               </a:rPr>
-              <a:t>11 / 14</a:t>
+              <a:t>12 / 15</a:t>
             </a:r>
             <a:endParaRPr lang="en-US" sz="900" dirty="0"/>
           </a:p>
@@ -6955,9 +9038,9 @@
 </p:sld>
 </file>
 
-<file path=ppt/slides/slide12.xml><?xml version="1.0" encoding="utf-8"?>
+<file path=ppt/slides/slide13.xml><?xml version="1.0" encoding="utf-8"?>
 <p:sld xmlns:a="http://schemas.openxmlformats.org/drawingml/2006/main" xmlns:r="http://schemas.openxmlformats.org/officeDocument/2006/relationships" xmlns:p="http://schemas.openxmlformats.org/presentationml/2006/main">
-  <p:cSld name="Slide 12">
+  <p:cSld name="Slide 13">
     <p:bg>
       <p:bgPr>
         <a:solidFill>
@@ -7059,7 +9142,7 @@
       </p:sp>
       <p:graphicFrame>
         <p:nvGraphicFramePr>
-          <p:cNvPr id="13" name="Table 0"/>
+          <p:cNvPr id="14" name="Table 0"/>
           <p:cNvGraphicFramePr>
             <a:graphicFrameLocks noGrp="1"/>
           </p:cNvGraphicFramePr>
@@ -9739,7 +11822,7 @@
                 <a:ea typeface="Microsoft JhengHei" pitchFamily="34" charset="-122"/>
                 <a:cs typeface="Microsoft JhengHei" pitchFamily="34" charset="-120"/>
               </a:rPr>
-              <a:t>12 / 14</a:t>
+              <a:t>13 / 15</a:t>
             </a:r>
             <a:endParaRPr lang="en-US" sz="900" dirty="0"/>
           </a:p>
@@ -9753,9 +11836,9 @@
 </p:sld>
 </file>
 
-<file path=ppt/slides/slide13.xml><?xml version="1.0" encoding="utf-8"?>
+<file path=ppt/slides/slide14.xml><?xml version="1.0" encoding="utf-8"?>
 <p:sld xmlns:a="http://schemas.openxmlformats.org/drawingml/2006/main" xmlns:r="http://schemas.openxmlformats.org/officeDocument/2006/relationships" xmlns:p="http://schemas.openxmlformats.org/presentationml/2006/main">
-  <p:cSld name="Slide 13">
+  <p:cSld name="Slide 14">
     <p:bg>
       <p:bgPr>
         <a:solidFill>
@@ -9873,7 +11956,7 @@
       </p:graphicFrame>
       <p:graphicFrame>
         <p:nvGraphicFramePr>
-          <p:cNvPr id="14" name="Table 0"/>
+          <p:cNvPr id="15" name="Table 0"/>
           <p:cNvGraphicFramePr>
             <a:graphicFrameLocks noGrp="1"/>
           </p:cNvGraphicFramePr>
@@ -11885,7 +13968,7 @@
                 <a:ea typeface="Microsoft JhengHei" pitchFamily="34" charset="-122"/>
                 <a:cs typeface="Microsoft JhengHei" pitchFamily="34" charset="-120"/>
               </a:rPr>
-              <a:t>13 / 14</a:t>
+              <a:t>14 / 15</a:t>
             </a:r>
             <a:endParaRPr lang="en-US" sz="900" dirty="0"/>
           </a:p>
@@ -11899,9 +13982,9 @@
 </p:sld>
 </file>
 
-<file path=ppt/slides/slide14.xml><?xml version="1.0" encoding="utf-8"?>
+<file path=ppt/slides/slide15.xml><?xml version="1.0" encoding="utf-8"?>
 <p:sld xmlns:a="http://schemas.openxmlformats.org/drawingml/2006/main" xmlns:r="http://schemas.openxmlformats.org/officeDocument/2006/relationships" xmlns:p="http://schemas.openxmlformats.org/presentationml/2006/main">
-  <p:cSld name="Slide 14">
+  <p:cSld name="Slide 15">
     <p:bg>
       <p:bgPr>
         <a:solidFill>
@@ -13217,7 +15300,7 @@
                 <a:ea typeface="Microsoft JhengHei" pitchFamily="34" charset="-122"/>
                 <a:cs typeface="Microsoft JhengHei" pitchFamily="34" charset="-120"/>
               </a:rPr>
-              <a:t>14 / 14</a:t>
+              <a:t>15 / 15</a:t>
             </a:r>
             <a:endParaRPr lang="en-US" sz="900" dirty="0"/>
           </a:p>
@@ -15114,7 +17197,7 @@
                 <a:ea typeface="Microsoft JhengHei" pitchFamily="34" charset="-122"/>
                 <a:cs typeface="Microsoft JhengHei" pitchFamily="34" charset="-120"/>
               </a:rPr>
-              <a:t>2 / 14</a:t>
+              <a:t>2 / 15</a:t>
             </a:r>
             <a:endParaRPr lang="en-US" sz="900" dirty="0"/>
           </a:p>
@@ -15832,7 +17915,7 @@
                 <a:ea typeface="Microsoft JhengHei" pitchFamily="34" charset="-122"/>
                 <a:cs typeface="Microsoft JhengHei" pitchFamily="34" charset="-120"/>
               </a:rPr>
-              <a:t>3 / 14</a:t>
+              <a:t>3 / 15</a:t>
             </a:r>
             <a:endParaRPr lang="en-US" sz="900" dirty="0"/>
           </a:p>
@@ -16810,7 +18893,7 @@
                 <a:ea typeface="Microsoft JhengHei" pitchFamily="34" charset="-122"/>
                 <a:cs typeface="Microsoft JhengHei" pitchFamily="34" charset="-120"/>
               </a:rPr>
-              <a:t>4 / 14</a:t>
+              <a:t>4 / 15</a:t>
             </a:r>
             <a:endParaRPr lang="en-US" sz="900" dirty="0"/>
           </a:p>
@@ -18472,7 +20555,7 @@
                 <a:ea typeface="Microsoft JhengHei" pitchFamily="34" charset="-122"/>
                 <a:cs typeface="Microsoft JhengHei" pitchFamily="34" charset="-120"/>
               </a:rPr>
-              <a:t>5 / 14</a:t>
+              <a:t>5 / 15</a:t>
             </a:r>
             <a:endParaRPr lang="en-US" sz="900" dirty="0"/>
           </a:p>
@@ -20351,7 +22434,7 @@
                 <a:ea typeface="Microsoft JhengHei" pitchFamily="34" charset="-122"/>
                 <a:cs typeface="Microsoft JhengHei" pitchFamily="34" charset="-120"/>
               </a:rPr>
-              <a:t>6 / 14</a:t>
+              <a:t>6 / 15</a:t>
             </a:r>
             <a:endParaRPr lang="en-US" sz="900" dirty="0"/>
           </a:p>
@@ -21961,7 +24044,7 @@
                 <a:ea typeface="Microsoft JhengHei" pitchFamily="34" charset="-122"/>
                 <a:cs typeface="Microsoft JhengHei" pitchFamily="34" charset="-120"/>
               </a:rPr>
-              <a:t>7 / 14</a:t>
+              <a:t>7 / 15</a:t>
             </a:r>
             <a:endParaRPr lang="en-US" sz="900" dirty="0"/>
           </a:p>
@@ -22380,7 +24463,7 @@
                 <a:ea typeface="Microsoft JhengHei" pitchFamily="34" charset="-122"/>
                 <a:cs typeface="Microsoft JhengHei" pitchFamily="34" charset="-120"/>
               </a:rPr>
-              <a:t>8 / 14</a:t>
+              <a:t>8 / 15</a:t>
             </a:r>
             <a:endParaRPr lang="en-US" sz="900" dirty="0"/>
           </a:p>
@@ -23949,7 +26032,7 @@
                 <a:ea typeface="Microsoft JhengHei" pitchFamily="34" charset="-122"/>
                 <a:cs typeface="Microsoft JhengHei" pitchFamily="34" charset="-120"/>
               </a:rPr>
-              <a:t>9 / 14</a:t>
+              <a:t>9 / 15</a:t>
             </a:r>
             <a:endParaRPr lang="en-US" sz="900" dirty="0"/>
           </a:p>

</xml_diff>